<commit_message>
Update existing slides to match notebook results
</commit_message>
<xml_diff>
--- a/presentation/Phishing_Website_Detection.pptx
+++ b/presentation/Phishing_Website_Detection.pptx
@@ -2,22 +2,22 @@
 <file path=ppt/presentation.xml><?xml version="1.0" encoding="utf-8"?>
 <p:presentation xmlns:p="http://schemas.openxmlformats.org/presentationml/2006/main">
   <p:sldMasterIdLst>
-    <p:sldMasterId xmlns:r="http://schemas.openxmlformats.org/officeDocument/2006/relationships" id="2147483648" r:id="Re1d1382800f8436e"/>
+    <p:sldMasterId xmlns:r="http://schemas.openxmlformats.org/officeDocument/2006/relationships" id="2147483648" r:id="Raa18e49a038a4c4e"/>
   </p:sldMasterIdLst>
   <p:notesMasterIdLst>
-    <p:notesMasterId xmlns:r="http://schemas.openxmlformats.org/officeDocument/2006/relationships" r:id="Raed875e02114485a"/>
+    <p:notesMasterId xmlns:r="http://schemas.openxmlformats.org/officeDocument/2006/relationships" r:id="R661e0ebb7e7c4801"/>
   </p:notesMasterIdLst>
   <p:sldIdLst>
-    <p:sldId xmlns:r="http://schemas.openxmlformats.org/officeDocument/2006/relationships" id="256" r:id="R9ba1759c19be4228"/>
-    <p:sldId xmlns:r="http://schemas.openxmlformats.org/officeDocument/2006/relationships" id="257" r:id="R1adca67630504b4c"/>
-    <p:sldId xmlns:r="http://schemas.openxmlformats.org/officeDocument/2006/relationships" id="258" r:id="Re53eeeddb5e74b5f"/>
-    <p:sldId xmlns:r="http://schemas.openxmlformats.org/officeDocument/2006/relationships" id="259" r:id="R281caad6eca7428d"/>
-    <p:sldId xmlns:r="http://schemas.openxmlformats.org/officeDocument/2006/relationships" id="260" r:id="R02d7bd49fdc745f7"/>
-    <p:sldId xmlns:r="http://schemas.openxmlformats.org/officeDocument/2006/relationships" id="261" r:id="R26fa58506ee24734"/>
-    <p:sldId xmlns:r="http://schemas.openxmlformats.org/officeDocument/2006/relationships" id="262" r:id="R16ae538a304e4484"/>
-    <p:sldId xmlns:r="http://schemas.openxmlformats.org/officeDocument/2006/relationships" id="263" r:id="R9c99e4e5f7b14fc7"/>
-    <p:sldId xmlns:r="http://schemas.openxmlformats.org/officeDocument/2006/relationships" id="264" r:id="R69aa2b0a074f4b2c"/>
-    <p:sldId xmlns:r="http://schemas.openxmlformats.org/officeDocument/2006/relationships" id="265" r:id="R544075970983466b"/>
+    <p:sldId xmlns:r="http://schemas.openxmlformats.org/officeDocument/2006/relationships" id="256" r:id="Ra383bbc61cbc4513"/>
+    <p:sldId xmlns:r="http://schemas.openxmlformats.org/officeDocument/2006/relationships" id="257" r:id="Rd7d9dac4fe2a4678"/>
+    <p:sldId xmlns:r="http://schemas.openxmlformats.org/officeDocument/2006/relationships" id="258" r:id="R58a4dabe17fb4596"/>
+    <p:sldId xmlns:r="http://schemas.openxmlformats.org/officeDocument/2006/relationships" id="259" r:id="R9fa7a9c0b194468b"/>
+    <p:sldId xmlns:r="http://schemas.openxmlformats.org/officeDocument/2006/relationships" id="260" r:id="R638dc464a2764967"/>
+    <p:sldId xmlns:r="http://schemas.openxmlformats.org/officeDocument/2006/relationships" id="261" r:id="R165c202f5c2a41d9"/>
+    <p:sldId xmlns:r="http://schemas.openxmlformats.org/officeDocument/2006/relationships" id="262" r:id="R38a0c2dfb6684f8a"/>
+    <p:sldId xmlns:r="http://schemas.openxmlformats.org/officeDocument/2006/relationships" id="263" r:id="Rb43ddd7b3c8a4be8"/>
+    <p:sldId xmlns:r="http://schemas.openxmlformats.org/officeDocument/2006/relationships" id="264" r:id="Rd570e625c5cc4580"/>
+    <p:sldId xmlns:r="http://schemas.openxmlformats.org/officeDocument/2006/relationships" id="265" r:id="R7c9ee28951bc43b1"/>
   </p:sldIdLst>
   <p:sldSz cx="12192000" cy="6858000"/>
   <p:notesSz cx="6858000" cy="9144000"/>
@@ -941,7 +941,7 @@
           <a:lstStyle xmlns:a="http://schemas.openxmlformats.org/drawingml/2006/main"/>
           <a:p xmlns:a="http://schemas.openxmlformats.org/drawingml/2006/main">
             <a:r>
-              <a:t>Single grouped holdout, seed 42, default 0.5 threshold. Test confusion counts: Logistic Regression TN=1,156 FP=76 FN=99 TP=881. Random Forest TN=1,201 FP=31 FN=75 TP=905. Higher benchmark scores are not proof of current real-world generalization.</a:t>
+              <a:t>Single grouped holdout, seed 42, default 0.5 threshold. Test confusion counts: Logistic Regression TN=1,101 FP=102 FN=70 TP=923. Random Forest TN=1,143 FP=60 FN=63 TP=930. Higher benchmark scores are not proof of current real-world generalization.</a:t>
             </a:r>
           </a:p>
         </p:txBody>
@@ -1011,7 +1011,7 @@
           <a:lstStyle xmlns:a="http://schemas.openxmlformats.org/drawingml/2006/main"/>
           <a:p xmlns:a="http://schemas.openxmlformats.org/drawingml/2006/main">
             <a:r>
-              <a:t>With phishing as positive, a false negative is a missed phishing example. A false positive is a legitimate site flagged. Random Forest misses 75 phishing cases and flags 31 legitimate cases in this test fold. A real system must set its threshold using workload and harm costs; neither class should be managed using accuracy alone.</a:t>
+              <a:t>With phishing as positive, a false negative is a missed phishing example. A false positive is a legitimate site flagged. Random Forest misses 63 phishing cases and flags 60 legitimate cases in this test fold. A real system must set its threshold using workload and harm costs; neither class should be managed using accuracy alone.</a:t>
             </a:r>
           </a:p>
         </p:txBody>
@@ -1081,7 +1081,7 @@
           <a:lstStyle xmlns:a="http://schemas.openxmlformats.org/drawingml/2006/main"/>
           <a:p xmlns:a="http://schemas.openxmlformats.org/drawingml/2006/main">
             <a:r>
-              <a:t>Random Forest held-out permutation importance: SSLfinal_State mean AUC drop 0.0636; URL_of_Anchor 0.0563; web_traffic 0.0144; Links_in_tags 0.0097; Prefix_Suffix 0.0094. These are predictive associations. The benchmark is historical, static, and has no timestamps or source groups, so the experiment cannot show detection of future attack campaigns.</a:t>
+              <a:t>Random Forest held-out permutation importance: SSLfinal_State mean AUC drop 0.0691; URL_of_Anchor 0.0610; web_traffic 0.0132; Prefix_Suffix 0.0116; Links_in_tags 0.0062. These are predictive associations. The benchmark is historical, static, and has no timestamps or source groups, so the experiment cannot show detection of future attack campaigns.</a:t>
             </a:r>
           </a:p>
         </p:txBody>
@@ -1128,7 +1128,7 @@
           <p:cNvPr id="3" name="Title">
             <a:extLst xmlns:a="http://schemas.openxmlformats.org/drawingml/2006/main">
               <a:ext uri="{FF2B5EF4-FFF2-40B4-BE49-F238E27FC236}">
-                <a16:creationId xmlns:a16="http://schemas.microsoft.com/office/drawing/2014/main" id="{B2906467-0B6F-4F6C-B1AD-24B3C512DA50}"/>
+                <a16:creationId xmlns:a16="http://schemas.microsoft.com/office/drawing/2014/main" id="{CE02ADA3-ADB4-428A-8C3B-A2B08ACBE6AA}"/>
               </a:ext>
             </a:extLst>
           </p:cNvPr>
@@ -1285,7 +1285,7 @@
           <p:cNvPr id="2" name="Subtitle">
             <a:extLst xmlns:a="http://schemas.openxmlformats.org/drawingml/2006/main">
               <a:ext uri="{FF2B5EF4-FFF2-40B4-BE49-F238E27FC236}">
-                <a16:creationId xmlns:a16="http://schemas.microsoft.com/office/drawing/2014/main" id="{44455024-0000-4E41-AF70-712B8A843911}"/>
+                <a16:creationId xmlns:a16="http://schemas.microsoft.com/office/drawing/2014/main" id="{6072C5AA-0313-4D99-9373-46D27F749B05}"/>
               </a:ext>
             </a:extLst>
           </p:cNvPr>
@@ -1459,7 +1459,7 @@
           <p:cNvPr id="2" name="Section title">
             <a:extLst xmlns:a="http://schemas.openxmlformats.org/drawingml/2006/main">
               <a:ext uri="{FF2B5EF4-FFF2-40B4-BE49-F238E27FC236}">
-                <a16:creationId xmlns:a16="http://schemas.microsoft.com/office/drawing/2014/main" id="{37D4BF1E-A1B0-459D-9CC4-5F12C0A82D1B}"/>
+                <a16:creationId xmlns:a16="http://schemas.microsoft.com/office/drawing/2014/main" id="{75C47FF2-95BF-4074-8EB3-BB9CC17267B4}"/>
               </a:ext>
             </a:extLst>
           </p:cNvPr>
@@ -1633,7 +1633,7 @@
           <p:cNvPr id="3" name="Title">
             <a:extLst xmlns:a="http://schemas.openxmlformats.org/drawingml/2006/main">
               <a:ext uri="{FF2B5EF4-FFF2-40B4-BE49-F238E27FC236}">
-                <a16:creationId xmlns:a16="http://schemas.microsoft.com/office/drawing/2014/main" id="{0F9DA057-3AED-471A-95C8-EB6C9C3CB98F}"/>
+                <a16:creationId xmlns:a16="http://schemas.microsoft.com/office/drawing/2014/main" id="{217B09C2-AA25-414C-8174-E9F52A7C39C7}"/>
               </a:ext>
             </a:extLst>
           </p:cNvPr>
@@ -1790,7 +1790,7 @@
           <p:cNvPr id="2" name="Body">
             <a:extLst xmlns:a="http://schemas.openxmlformats.org/drawingml/2006/main">
               <a:ext uri="{FF2B5EF4-FFF2-40B4-BE49-F238E27FC236}">
-                <a16:creationId xmlns:a16="http://schemas.microsoft.com/office/drawing/2014/main" id="{24A5DA91-747C-4267-94B8-7884BC915B2E}"/>
+                <a16:creationId xmlns:a16="http://schemas.microsoft.com/office/drawing/2014/main" id="{28484734-C29D-47D7-AFAB-D2D4B57F70C3}"/>
               </a:ext>
             </a:extLst>
           </p:cNvPr>
@@ -1964,7 +1964,7 @@
           <p:cNvPr id="4" name="Title">
             <a:extLst xmlns:a="http://schemas.openxmlformats.org/drawingml/2006/main">
               <a:ext uri="{FF2B5EF4-FFF2-40B4-BE49-F238E27FC236}">
-                <a16:creationId xmlns:a16="http://schemas.microsoft.com/office/drawing/2014/main" id="{F3D3F622-B8A6-445D-B530-88C3BEAE0DD1}"/>
+                <a16:creationId xmlns:a16="http://schemas.microsoft.com/office/drawing/2014/main" id="{DAF55A35-79EA-4DCE-B6D0-00E0D8433ADD}"/>
               </a:ext>
             </a:extLst>
           </p:cNvPr>
@@ -2121,7 +2121,7 @@
           <p:cNvPr id="2" name="Left column">
             <a:extLst xmlns:a="http://schemas.openxmlformats.org/drawingml/2006/main">
               <a:ext uri="{FF2B5EF4-FFF2-40B4-BE49-F238E27FC236}">
-                <a16:creationId xmlns:a16="http://schemas.microsoft.com/office/drawing/2014/main" id="{6F422560-2754-41A6-9910-7ADFF3E75DE9}"/>
+                <a16:creationId xmlns:a16="http://schemas.microsoft.com/office/drawing/2014/main" id="{9882021E-A83E-4C6F-B180-7C284D34D101}"/>
               </a:ext>
             </a:extLst>
           </p:cNvPr>
@@ -2278,7 +2278,7 @@
           <p:cNvPr id="3" name="Right column">
             <a:extLst xmlns:a="http://schemas.openxmlformats.org/drawingml/2006/main">
               <a:ext uri="{FF2B5EF4-FFF2-40B4-BE49-F238E27FC236}">
-                <a16:creationId xmlns:a16="http://schemas.microsoft.com/office/drawing/2014/main" id="{B8961E4E-10FF-4566-B70A-91523BFFCC77}"/>
+                <a16:creationId xmlns:a16="http://schemas.microsoft.com/office/drawing/2014/main" id="{F5D75BDB-4EA6-4FBA-A05D-3B98F02E7406}"/>
               </a:ext>
             </a:extLst>
           </p:cNvPr>
@@ -2452,7 +2452,7 @@
           <p:cNvPr id="3" name="Title">
             <a:extLst xmlns:a="http://schemas.openxmlformats.org/drawingml/2006/main">
               <a:ext uri="{FF2B5EF4-FFF2-40B4-BE49-F238E27FC236}">
-                <a16:creationId xmlns:a16="http://schemas.microsoft.com/office/drawing/2014/main" id="{57745A01-DCFC-4A13-B842-39D08141FB61}"/>
+                <a16:creationId xmlns:a16="http://schemas.microsoft.com/office/drawing/2014/main" id="{872F5CC1-57D9-4FBA-9925-79C03050C774}"/>
               </a:ext>
             </a:extLst>
           </p:cNvPr>
@@ -2609,7 +2609,7 @@
           <p:cNvPr id="2" name="Left column">
             <a:extLst xmlns:a="http://schemas.openxmlformats.org/drawingml/2006/main">
               <a:ext uri="{FF2B5EF4-FFF2-40B4-BE49-F238E27FC236}">
-                <a16:creationId xmlns:a16="http://schemas.microsoft.com/office/drawing/2014/main" id="{13104526-9B8B-4D47-834E-E714B4D3BD5A}"/>
+                <a16:creationId xmlns:a16="http://schemas.microsoft.com/office/drawing/2014/main" id="{054D547A-092D-48F8-A34D-64D2C6404F51}"/>
               </a:ext>
             </a:extLst>
           </p:cNvPr>
@@ -2804,12 +2804,12 @@
   </p:cSld>
   <p:clrMap bg1="lt1" tx1="dk1" bg2="lt2" tx2="dk2" accent1="accent1" accent2="accent2" accent3="accent3" accent4="accent4" accent5="accent5" accent6="accent6" hlink="hlink" folHlink="folHlink"/>
   <p:sldLayoutIdLst>
-    <p:sldLayoutId xmlns:r="http://schemas.openxmlformats.org/officeDocument/2006/relationships" id="2147483649" r:id="R2501720abf314ac5"/>
-    <p:sldLayoutId xmlns:r="http://schemas.openxmlformats.org/officeDocument/2006/relationships" id="2147483650" r:id="Rcaa2c29ae6564faf"/>
-    <p:sldLayoutId xmlns:r="http://schemas.openxmlformats.org/officeDocument/2006/relationships" id="2147483651" r:id="R20a5d317a87347f5"/>
-    <p:sldLayoutId xmlns:r="http://schemas.openxmlformats.org/officeDocument/2006/relationships" id="2147483652" r:id="R0b02ffcda3e64382"/>
-    <p:sldLayoutId xmlns:r="http://schemas.openxmlformats.org/officeDocument/2006/relationships" id="2147483653" r:id="Rf3705037783a4460"/>
-    <p:sldLayoutId xmlns:r="http://schemas.openxmlformats.org/officeDocument/2006/relationships" id="2147483654" r:id="R17cc698e0ea64953"/>
+    <p:sldLayoutId xmlns:r="http://schemas.openxmlformats.org/officeDocument/2006/relationships" id="2147483649" r:id="R99aafab5f2604d98"/>
+    <p:sldLayoutId xmlns:r="http://schemas.openxmlformats.org/officeDocument/2006/relationships" id="2147483650" r:id="R95ab6f0ba81747df"/>
+    <p:sldLayoutId xmlns:r="http://schemas.openxmlformats.org/officeDocument/2006/relationships" id="2147483651" r:id="Rc56fab1889094834"/>
+    <p:sldLayoutId xmlns:r="http://schemas.openxmlformats.org/officeDocument/2006/relationships" id="2147483652" r:id="R8edda5fa23534bec"/>
+    <p:sldLayoutId xmlns:r="http://schemas.openxmlformats.org/officeDocument/2006/relationships" id="2147483653" r:id="Re91ee22ff81540e9"/>
+    <p:sldLayoutId xmlns:r="http://schemas.openxmlformats.org/officeDocument/2006/relationships" id="2147483654" r:id="R712bb5822b3a464e"/>
   </p:sldLayoutIdLst>
   <p:txStyles>
     <p:titleStyle>
@@ -3360,7 +3360,7 @@
           <p:cNvPr id="8" name="">
             <a:extLst xmlns:a="http://schemas.openxmlformats.org/drawingml/2006/main">
               <a:ext uri="{FF2B5EF4-FFF2-40B4-BE49-F238E27FC236}">
-                <a16:creationId xmlns:a16="http://schemas.microsoft.com/office/drawing/2014/main" id="{E09BC6D0-B802-4F39-8641-75D9AF932F6D}"/>
+                <a16:creationId xmlns:a16="http://schemas.microsoft.com/office/drawing/2014/main" id="{3AEC0C27-D3DB-43DC-8701-DEFDF1C50800}"/>
               </a:ext>
             </a:extLst>
           </p:cNvPr>
@@ -3429,7 +3429,7 @@
           <p:cNvPr id="2" name="">
             <a:extLst xmlns:a="http://schemas.openxmlformats.org/drawingml/2006/main">
               <a:ext uri="{FF2B5EF4-FFF2-40B4-BE49-F238E27FC236}">
-                <a16:creationId xmlns:a16="http://schemas.microsoft.com/office/drawing/2014/main" id="{7529A784-E2CF-4006-9ADC-95768BB4FE13}"/>
+                <a16:creationId xmlns:a16="http://schemas.microsoft.com/office/drawing/2014/main" id="{BD9A8BDD-24EE-427C-B8C2-BC65F22B0F3C}"/>
               </a:ext>
             </a:extLst>
           </p:cNvPr>
@@ -3498,7 +3498,7 @@
           <p:cNvPr id="3" name="">
             <a:extLst xmlns:a="http://schemas.openxmlformats.org/drawingml/2006/main">
               <a:ext uri="{FF2B5EF4-FFF2-40B4-BE49-F238E27FC236}">
-                <a16:creationId xmlns:a16="http://schemas.microsoft.com/office/drawing/2014/main" id="{9D15AF04-EA33-4D89-9C2B-1EE51264D473}"/>
+                <a16:creationId xmlns:a16="http://schemas.microsoft.com/office/drawing/2014/main" id="{F30F17FD-3FFB-46E5-96E8-17A41D967B75}"/>
               </a:ext>
             </a:extLst>
           </p:cNvPr>
@@ -3567,7 +3567,7 @@
           <p:cNvPr id="4" name="">
             <a:extLst xmlns:a="http://schemas.openxmlformats.org/drawingml/2006/main">
               <a:ext uri="{FF2B5EF4-FFF2-40B4-BE49-F238E27FC236}">
-                <a16:creationId xmlns:a16="http://schemas.microsoft.com/office/drawing/2014/main" id="{F226AE0F-D1BD-4458-9B7F-60656B789E2E}"/>
+                <a16:creationId xmlns:a16="http://schemas.microsoft.com/office/drawing/2014/main" id="{93EEEF2C-A83A-41BB-AFCC-B2C335557B79}"/>
               </a:ext>
             </a:extLst>
           </p:cNvPr>
@@ -3598,7 +3598,7 @@
           <p:cNvPr id="5" name="">
             <a:extLst xmlns:a="http://schemas.openxmlformats.org/drawingml/2006/main">
               <a:ext uri="{FF2B5EF4-FFF2-40B4-BE49-F238E27FC236}">
-                <a16:creationId xmlns:a16="http://schemas.microsoft.com/office/drawing/2014/main" id="{369D0BEC-0F2B-4D6C-B48A-0C5B117B353C}"/>
+                <a16:creationId xmlns:a16="http://schemas.microsoft.com/office/drawing/2014/main" id="{5B865063-DF6D-4706-8B5C-C3596EE8AE59}"/>
               </a:ext>
             </a:extLst>
           </p:cNvPr>
@@ -3667,7 +3667,7 @@
           <p:cNvPr id="6" name="">
             <a:extLst xmlns:a="http://schemas.openxmlformats.org/drawingml/2006/main">
               <a:ext uri="{FF2B5EF4-FFF2-40B4-BE49-F238E27FC236}">
-                <a16:creationId xmlns:a16="http://schemas.microsoft.com/office/drawing/2014/main" id="{92A93D51-D28B-4356-A549-5A8DB2522D63}"/>
+                <a16:creationId xmlns:a16="http://schemas.microsoft.com/office/drawing/2014/main" id="{950EA884-F514-46AE-B17A-C638223681AC}"/>
               </a:ext>
             </a:extLst>
           </p:cNvPr>
@@ -3736,7 +3736,7 @@
           <p:cNvPr id="7" name="">
             <a:extLst xmlns:a="http://schemas.openxmlformats.org/drawingml/2006/main">
               <a:ext uri="{FF2B5EF4-FFF2-40B4-BE49-F238E27FC236}">
-                <a16:creationId xmlns:a16="http://schemas.microsoft.com/office/drawing/2014/main" id="{E0661C46-034B-41E1-80F2-FE70AB6BEA8A}"/>
+                <a16:creationId xmlns:a16="http://schemas.microsoft.com/office/drawing/2014/main" id="{7C5DA5A2-34BF-49BA-83DB-E321806CE52B}"/>
               </a:ext>
             </a:extLst>
           </p:cNvPr>
@@ -3803,7 +3803,7 @@
     </p:spTree>
     <p:extLst>
       <p:ext uri="{BB962C8B-B14F-4D97-AF65-F5344CB8AC3E}">
-        <p14:creationId xmlns:p14="http://schemas.microsoft.com/office/powerpoint/2010/main" val="760509497"/>
+        <p14:creationId xmlns:p14="http://schemas.microsoft.com/office/powerpoint/2010/main" val="234211142"/>
       </p:ext>
     </p:extLst>
   </p:cSld>
@@ -3834,7 +3834,7 @@
           <p:cNvPr id="11" name="">
             <a:extLst xmlns:a="http://schemas.openxmlformats.org/drawingml/2006/main">
               <a:ext uri="{FF2B5EF4-FFF2-40B4-BE49-F238E27FC236}">
-                <a16:creationId xmlns:a16="http://schemas.microsoft.com/office/drawing/2014/main" id="{0BF0B9FF-1948-4BBD-9253-CC56960E581D}"/>
+                <a16:creationId xmlns:a16="http://schemas.microsoft.com/office/drawing/2014/main" id="{1417660F-5AFA-4628-B57F-FA197FB3B016}"/>
               </a:ext>
             </a:extLst>
           </p:cNvPr>
@@ -3903,7 +3903,7 @@
           <p:cNvPr id="2" name="">
             <a:extLst xmlns:a="http://schemas.openxmlformats.org/drawingml/2006/main">
               <a:ext uri="{FF2B5EF4-FFF2-40B4-BE49-F238E27FC236}">
-                <a16:creationId xmlns:a16="http://schemas.microsoft.com/office/drawing/2014/main" id="{CE099018-AEFA-4CAE-83DA-AAE19BD3F0B8}"/>
+                <a16:creationId xmlns:a16="http://schemas.microsoft.com/office/drawing/2014/main" id="{E32777EC-CCC6-450F-AA8F-34EB19A82247}"/>
               </a:ext>
             </a:extLst>
           </p:cNvPr>
@@ -3934,7 +3934,7 @@
           <p:cNvPr id="3" name="">
             <a:extLst xmlns:a="http://schemas.openxmlformats.org/drawingml/2006/main">
               <a:ext uri="{FF2B5EF4-FFF2-40B4-BE49-F238E27FC236}">
-                <a16:creationId xmlns:a16="http://schemas.microsoft.com/office/drawing/2014/main" id="{02920EE5-E941-4459-A74A-0CEA28B2BCE3}"/>
+                <a16:creationId xmlns:a16="http://schemas.microsoft.com/office/drawing/2014/main" id="{50B6C707-E1D9-4FE9-A73E-C2FDDD9BBFFD}"/>
               </a:ext>
             </a:extLst>
           </p:cNvPr>
@@ -4003,7 +4003,7 @@
           <p:cNvPr id="4" name="">
             <a:extLst xmlns:a="http://schemas.openxmlformats.org/drawingml/2006/main">
               <a:ext uri="{FF2B5EF4-FFF2-40B4-BE49-F238E27FC236}">
-                <a16:creationId xmlns:a16="http://schemas.microsoft.com/office/drawing/2014/main" id="{D0F82ECF-1246-4BE5-BF55-E77F59234ACA}"/>
+                <a16:creationId xmlns:a16="http://schemas.microsoft.com/office/drawing/2014/main" id="{474E629B-8BD1-49D0-9BDA-77D9347C6D53}"/>
               </a:ext>
             </a:extLst>
           </p:cNvPr>
@@ -4072,7 +4072,7 @@
           <p:cNvPr id="5" name="">
             <a:extLst xmlns:a="http://schemas.openxmlformats.org/drawingml/2006/main">
               <a:ext uri="{FF2B5EF4-FFF2-40B4-BE49-F238E27FC236}">
-                <a16:creationId xmlns:a16="http://schemas.microsoft.com/office/drawing/2014/main" id="{25F68E7A-1FBE-456C-A84C-799FF935D4AB}"/>
+                <a16:creationId xmlns:a16="http://schemas.microsoft.com/office/drawing/2014/main" id="{95410265-8955-406E-9DB9-F3FAAC1CFC45}"/>
               </a:ext>
             </a:extLst>
           </p:cNvPr>
@@ -4131,7 +4131,7 @@
                 <a:ea typeface="Arial"/>
                 <a:cs typeface="Arial"/>
               </a:rPr>
-              <a:t>0.952 accuracy  ·  0.923 phishing recall  ·  75 missed phishing cases</a:t>
+              <a:t>0.944 accuracy  ·  0.937 phishing recall  ·  63 missed phishing cases</a:t>
             </a:r>
           </a:p>
         </p:txBody>
@@ -4141,7 +4141,7 @@
           <p:cNvPr id="6" name="">
             <a:extLst xmlns:a="http://schemas.openxmlformats.org/drawingml/2006/main">
               <a:ext uri="{FF2B5EF4-FFF2-40B4-BE49-F238E27FC236}">
-                <a16:creationId xmlns:a16="http://schemas.microsoft.com/office/drawing/2014/main" id="{9A97BBBB-E52D-46C5-BA26-9C044477F1E6}"/>
+                <a16:creationId xmlns:a16="http://schemas.microsoft.com/office/drawing/2014/main" id="{6FEC3C0E-E4B8-4D38-8361-CFD819681284}"/>
               </a:ext>
             </a:extLst>
           </p:cNvPr>
@@ -4210,7 +4210,7 @@
           <p:cNvPr id="7" name="">
             <a:extLst xmlns:a="http://schemas.openxmlformats.org/drawingml/2006/main">
               <a:ext uri="{FF2B5EF4-FFF2-40B4-BE49-F238E27FC236}">
-                <a16:creationId xmlns:a16="http://schemas.microsoft.com/office/drawing/2014/main" id="{4E0E11F7-FC9E-4705-94C7-4B03AE437E96}"/>
+                <a16:creationId xmlns:a16="http://schemas.microsoft.com/office/drawing/2014/main" id="{3A5634FD-A6CA-46FD-83CD-F0CE79BB129F}"/>
               </a:ext>
             </a:extLst>
           </p:cNvPr>
@@ -4279,7 +4279,7 @@
           <p:cNvPr id="8" name="">
             <a:extLst xmlns:a="http://schemas.openxmlformats.org/drawingml/2006/main">
               <a:ext uri="{FF2B5EF4-FFF2-40B4-BE49-F238E27FC236}">
-                <a16:creationId xmlns:a16="http://schemas.microsoft.com/office/drawing/2014/main" id="{39B852AB-BEAF-454A-B3D8-B9C313F1458A}"/>
+                <a16:creationId xmlns:a16="http://schemas.microsoft.com/office/drawing/2014/main" id="{33179E60-DA26-476F-B0F1-B820459346E3}"/>
               </a:ext>
             </a:extLst>
           </p:cNvPr>
@@ -4310,7 +4310,7 @@
           <p:cNvPr id="9" name="">
             <a:extLst xmlns:a="http://schemas.openxmlformats.org/drawingml/2006/main">
               <a:ext uri="{FF2B5EF4-FFF2-40B4-BE49-F238E27FC236}">
-                <a16:creationId xmlns:a16="http://schemas.microsoft.com/office/drawing/2014/main" id="{1E198B6A-0269-4909-AFCC-0C871BCBB7CA}"/>
+                <a16:creationId xmlns:a16="http://schemas.microsoft.com/office/drawing/2014/main" id="{1771859C-72B2-4EC5-A9FC-C79746B568ED}"/>
               </a:ext>
             </a:extLst>
           </p:cNvPr>
@@ -4379,7 +4379,7 @@
           <p:cNvPr id="10" name="">
             <a:extLst xmlns:a="http://schemas.openxmlformats.org/drawingml/2006/main">
               <a:ext uri="{FF2B5EF4-FFF2-40B4-BE49-F238E27FC236}">
-                <a16:creationId xmlns:a16="http://schemas.microsoft.com/office/drawing/2014/main" id="{6CEAE94A-DCE5-4468-A890-62E207BF5C84}"/>
+                <a16:creationId xmlns:a16="http://schemas.microsoft.com/office/drawing/2014/main" id="{1C721B15-1C87-4673-849B-A7A60BAC7FC2}"/>
               </a:ext>
             </a:extLst>
           </p:cNvPr>
@@ -4446,7 +4446,7 @@
     </p:spTree>
     <p:extLst>
       <p:ext uri="{BB962C8B-B14F-4D97-AF65-F5344CB8AC3E}">
-        <p14:creationId xmlns:p14="http://schemas.microsoft.com/office/powerpoint/2010/main" val="531490610"/>
+        <p14:creationId xmlns:p14="http://schemas.microsoft.com/office/powerpoint/2010/main" val="292853298"/>
       </p:ext>
     </p:extLst>
   </p:cSld>
@@ -4477,7 +4477,7 @@
           <p:cNvPr id="12" name="">
             <a:extLst xmlns:a="http://schemas.openxmlformats.org/drawingml/2006/main">
               <a:ext uri="{FF2B5EF4-FFF2-40B4-BE49-F238E27FC236}">
-                <a16:creationId xmlns:a16="http://schemas.microsoft.com/office/drawing/2014/main" id="{D7C0DCF8-1224-4522-B1AD-1FFE75EF4747}"/>
+                <a16:creationId xmlns:a16="http://schemas.microsoft.com/office/drawing/2014/main" id="{EA419A20-502C-4F09-B218-B4B21B1829C0}"/>
               </a:ext>
             </a:extLst>
           </p:cNvPr>
@@ -4546,7 +4546,7 @@
           <p:cNvPr id="2" name="">
             <a:extLst xmlns:a="http://schemas.openxmlformats.org/drawingml/2006/main">
               <a:ext uri="{FF2B5EF4-FFF2-40B4-BE49-F238E27FC236}">
-                <a16:creationId xmlns:a16="http://schemas.microsoft.com/office/drawing/2014/main" id="{F14FFF7E-54D2-41C9-B018-B55CCECE80E9}"/>
+                <a16:creationId xmlns:a16="http://schemas.microsoft.com/office/drawing/2014/main" id="{6521FCB7-6DAF-44E0-9D25-971034715EE6}"/>
               </a:ext>
             </a:extLst>
           </p:cNvPr>
@@ -4577,7 +4577,7 @@
           <p:cNvPr id="3" name="">
             <a:extLst xmlns:a="http://schemas.openxmlformats.org/drawingml/2006/main">
               <a:ext uri="{FF2B5EF4-FFF2-40B4-BE49-F238E27FC236}">
-                <a16:creationId xmlns:a16="http://schemas.microsoft.com/office/drawing/2014/main" id="{92706334-9744-4DBF-9F39-57C55892D35D}"/>
+                <a16:creationId xmlns:a16="http://schemas.microsoft.com/office/drawing/2014/main" id="{5A976AC9-223E-48BC-A709-BD2D553E6958}"/>
               </a:ext>
             </a:extLst>
           </p:cNvPr>
@@ -4646,7 +4646,7 @@
           <p:cNvPr id="4" name="">
             <a:extLst xmlns:a="http://schemas.openxmlformats.org/drawingml/2006/main">
               <a:ext uri="{FF2B5EF4-FFF2-40B4-BE49-F238E27FC236}">
-                <a16:creationId xmlns:a16="http://schemas.microsoft.com/office/drawing/2014/main" id="{07A6CFFB-189F-4B40-B99B-2FB7B69A172C}"/>
+                <a16:creationId xmlns:a16="http://schemas.microsoft.com/office/drawing/2014/main" id="{A4094159-6C1F-4AF0-8506-C43B971993C2}"/>
               </a:ext>
             </a:extLst>
           </p:cNvPr>
@@ -4715,7 +4715,7 @@
           <p:cNvPr id="5" name="">
             <a:extLst xmlns:a="http://schemas.openxmlformats.org/drawingml/2006/main">
               <a:ext uri="{FF2B5EF4-FFF2-40B4-BE49-F238E27FC236}">
-                <a16:creationId xmlns:a16="http://schemas.microsoft.com/office/drawing/2014/main" id="{CE20D5C5-EA60-4348-8BF4-9BEBF3105D08}"/>
+                <a16:creationId xmlns:a16="http://schemas.microsoft.com/office/drawing/2014/main" id="{0AE45D54-0F87-4F71-8AF1-9C819154BB47}"/>
               </a:ext>
             </a:extLst>
           </p:cNvPr>
@@ -4784,7 +4784,7 @@
           <p:cNvPr id="6" name="">
             <a:extLst xmlns:a="http://schemas.openxmlformats.org/drawingml/2006/main">
               <a:ext uri="{FF2B5EF4-FFF2-40B4-BE49-F238E27FC236}">
-                <a16:creationId xmlns:a16="http://schemas.microsoft.com/office/drawing/2014/main" id="{56AC6465-483B-4DB9-91A1-DA209C300294}"/>
+                <a16:creationId xmlns:a16="http://schemas.microsoft.com/office/drawing/2014/main" id="{051AA3B6-4D2B-4C1B-AF23-6F2AFFE4EFB4}"/>
               </a:ext>
             </a:extLst>
           </p:cNvPr>
@@ -4853,7 +4853,7 @@
           <p:cNvPr id="7" name="">
             <a:extLst xmlns:a="http://schemas.openxmlformats.org/drawingml/2006/main">
               <a:ext uri="{FF2B5EF4-FFF2-40B4-BE49-F238E27FC236}">
-                <a16:creationId xmlns:a16="http://schemas.microsoft.com/office/drawing/2014/main" id="{63461574-7CCB-4463-B3B4-08F85A0DD02E}"/>
+                <a16:creationId xmlns:a16="http://schemas.microsoft.com/office/drawing/2014/main" id="{91672723-7BAC-4723-B39A-E2E27DC6EEFC}"/>
               </a:ext>
             </a:extLst>
           </p:cNvPr>
@@ -4886,7 +4886,7 @@
           <p:cNvPr id="8" name="">
             <a:extLst xmlns:a="http://schemas.openxmlformats.org/drawingml/2006/main">
               <a:ext uri="{FF2B5EF4-FFF2-40B4-BE49-F238E27FC236}">
-                <a16:creationId xmlns:a16="http://schemas.microsoft.com/office/drawing/2014/main" id="{0CDA75C7-B5CE-439A-9A04-40491DAFDF40}"/>
+                <a16:creationId xmlns:a16="http://schemas.microsoft.com/office/drawing/2014/main" id="{2B2A01B1-7D49-44FE-986F-F85521CE964F}"/>
               </a:ext>
             </a:extLst>
           </p:cNvPr>
@@ -4955,7 +4955,7 @@
           <p:cNvPr id="9" name="">
             <a:extLst xmlns:a="http://schemas.openxmlformats.org/drawingml/2006/main">
               <a:ext uri="{FF2B5EF4-FFF2-40B4-BE49-F238E27FC236}">
-                <a16:creationId xmlns:a16="http://schemas.microsoft.com/office/drawing/2014/main" id="{30C35470-54AC-4FA5-B7E3-1DA8E0D63772}"/>
+                <a16:creationId xmlns:a16="http://schemas.microsoft.com/office/drawing/2014/main" id="{F4AA362A-E868-4993-A881-C0800F374AF7}"/>
               </a:ext>
             </a:extLst>
           </p:cNvPr>
@@ -5047,7 +5047,7 @@
           <p:cNvPr id="10" name="">
             <a:extLst xmlns:a="http://schemas.openxmlformats.org/drawingml/2006/main">
               <a:ext uri="{FF2B5EF4-FFF2-40B4-BE49-F238E27FC236}">
-                <a16:creationId xmlns:a16="http://schemas.microsoft.com/office/drawing/2014/main" id="{4C0BC2FE-3ADA-49BE-8892-DE9F0D05C6AE}"/>
+                <a16:creationId xmlns:a16="http://schemas.microsoft.com/office/drawing/2014/main" id="{CD32BE9C-165F-4817-8F1B-56018A26C5D6}"/>
               </a:ext>
             </a:extLst>
           </p:cNvPr>
@@ -5078,7 +5078,7 @@
           <p:cNvPr id="11" name="">
             <a:extLst xmlns:a="http://schemas.openxmlformats.org/drawingml/2006/main">
               <a:ext uri="{FF2B5EF4-FFF2-40B4-BE49-F238E27FC236}">
-                <a16:creationId xmlns:a16="http://schemas.microsoft.com/office/drawing/2014/main" id="{5CC80101-22F7-489A-901E-4AFC73363C2B}"/>
+                <a16:creationId xmlns:a16="http://schemas.microsoft.com/office/drawing/2014/main" id="{E976EE64-1878-4EC6-9CAC-09BCC3FB9C59}"/>
               </a:ext>
             </a:extLst>
           </p:cNvPr>
@@ -5168,7 +5168,7 @@
     </p:spTree>
     <p:extLst>
       <p:ext uri="{BB962C8B-B14F-4D97-AF65-F5344CB8AC3E}">
-        <p14:creationId xmlns:p14="http://schemas.microsoft.com/office/powerpoint/2010/main" val="2105537581"/>
+        <p14:creationId xmlns:p14="http://schemas.microsoft.com/office/powerpoint/2010/main" val="189978072"/>
       </p:ext>
     </p:extLst>
   </p:cSld>
@@ -5199,7 +5199,7 @@
           <p:cNvPr id="15" name="">
             <a:extLst xmlns:a="http://schemas.openxmlformats.org/drawingml/2006/main">
               <a:ext uri="{FF2B5EF4-FFF2-40B4-BE49-F238E27FC236}">
-                <a16:creationId xmlns:a16="http://schemas.microsoft.com/office/drawing/2014/main" id="{14E6D7A7-B8D7-4886-AD5A-08720498F1BF}"/>
+                <a16:creationId xmlns:a16="http://schemas.microsoft.com/office/drawing/2014/main" id="{0CB6AC79-A329-436F-B971-C7E90267D88F}"/>
               </a:ext>
             </a:extLst>
           </p:cNvPr>
@@ -5268,7 +5268,7 @@
           <p:cNvPr id="2" name="">
             <a:extLst xmlns:a="http://schemas.openxmlformats.org/drawingml/2006/main">
               <a:ext uri="{FF2B5EF4-FFF2-40B4-BE49-F238E27FC236}">
-                <a16:creationId xmlns:a16="http://schemas.microsoft.com/office/drawing/2014/main" id="{5ECE54C5-B5B5-44EF-B7F4-F4712BB369FB}"/>
+                <a16:creationId xmlns:a16="http://schemas.microsoft.com/office/drawing/2014/main" id="{4993EEA2-930D-47BE-AE29-D93F60E02095}"/>
               </a:ext>
             </a:extLst>
           </p:cNvPr>
@@ -5299,7 +5299,7 @@
           <p:cNvPr id="3" name="">
             <a:extLst xmlns:a="http://schemas.openxmlformats.org/drawingml/2006/main">
               <a:ext uri="{FF2B5EF4-FFF2-40B4-BE49-F238E27FC236}">
-                <a16:creationId xmlns:a16="http://schemas.microsoft.com/office/drawing/2014/main" id="{AB122063-1707-4943-AF30-ADD3339E6A69}"/>
+                <a16:creationId xmlns:a16="http://schemas.microsoft.com/office/drawing/2014/main" id="{20A89256-14ED-401D-B929-A5FEACAE141B}"/>
               </a:ext>
             </a:extLst>
           </p:cNvPr>
@@ -5368,7 +5368,7 @@
           <p:cNvPr id="4" name="">
             <a:extLst xmlns:a="http://schemas.openxmlformats.org/drawingml/2006/main">
               <a:ext uri="{FF2B5EF4-FFF2-40B4-BE49-F238E27FC236}">
-                <a16:creationId xmlns:a16="http://schemas.microsoft.com/office/drawing/2014/main" id="{037EAB3D-102C-4E1B-B2C6-3E6D2BF79E33}"/>
+                <a16:creationId xmlns:a16="http://schemas.microsoft.com/office/drawing/2014/main" id="{C753A4C0-592B-4E5C-AE0C-7A06D6B231F3}"/>
               </a:ext>
             </a:extLst>
           </p:cNvPr>
@@ -5437,7 +5437,7 @@
           <p:cNvPr id="5" name="">
             <a:extLst xmlns:a="http://schemas.openxmlformats.org/drawingml/2006/main">
               <a:ext uri="{FF2B5EF4-FFF2-40B4-BE49-F238E27FC236}">
-                <a16:creationId xmlns:a16="http://schemas.microsoft.com/office/drawing/2014/main" id="{AF6F81FF-E512-4F3C-9A81-2666E71836A7}"/>
+                <a16:creationId xmlns:a16="http://schemas.microsoft.com/office/drawing/2014/main" id="{C90CD6B4-D8E8-4F7F-9491-44576673BA2C}"/>
               </a:ext>
             </a:extLst>
           </p:cNvPr>
@@ -5506,7 +5506,7 @@
           <p:cNvPr id="6" name="">
             <a:extLst xmlns:a="http://schemas.openxmlformats.org/drawingml/2006/main">
               <a:ext uri="{FF2B5EF4-FFF2-40B4-BE49-F238E27FC236}">
-                <a16:creationId xmlns:a16="http://schemas.microsoft.com/office/drawing/2014/main" id="{87E310FF-102D-407B-93EC-FC222A38AC0D}"/>
+                <a16:creationId xmlns:a16="http://schemas.microsoft.com/office/drawing/2014/main" id="{617AC0F0-F7D8-44AB-9C59-910B782A6948}"/>
               </a:ext>
             </a:extLst>
           </p:cNvPr>
@@ -5575,7 +5575,7 @@
           <p:cNvPr id="7" name="">
             <a:extLst xmlns:a="http://schemas.openxmlformats.org/drawingml/2006/main">
               <a:ext uri="{FF2B5EF4-FFF2-40B4-BE49-F238E27FC236}">
-                <a16:creationId xmlns:a16="http://schemas.microsoft.com/office/drawing/2014/main" id="{6A8C9059-5C1B-4598-91EA-C3A2BD58811A}"/>
+                <a16:creationId xmlns:a16="http://schemas.microsoft.com/office/drawing/2014/main" id="{75297D78-7859-45BB-B017-B7C44798B911}"/>
               </a:ext>
             </a:extLst>
           </p:cNvPr>
@@ -5644,7 +5644,7 @@
           <p:cNvPr id="8" name="">
             <a:extLst xmlns:a="http://schemas.openxmlformats.org/drawingml/2006/main">
               <a:ext uri="{FF2B5EF4-FFF2-40B4-BE49-F238E27FC236}">
-                <a16:creationId xmlns:a16="http://schemas.microsoft.com/office/drawing/2014/main" id="{1A1E5A60-A0E3-4E58-8AD7-B38AB96A1ACE}"/>
+                <a16:creationId xmlns:a16="http://schemas.microsoft.com/office/drawing/2014/main" id="{5F69D4A1-3EAC-4547-8505-E87A6F34FA9C}"/>
               </a:ext>
             </a:extLst>
           </p:cNvPr>
@@ -5713,7 +5713,7 @@
           <p:cNvPr id="9" name="">
             <a:extLst xmlns:a="http://schemas.openxmlformats.org/drawingml/2006/main">
               <a:ext uri="{FF2B5EF4-FFF2-40B4-BE49-F238E27FC236}">
-                <a16:creationId xmlns:a16="http://schemas.microsoft.com/office/drawing/2014/main" id="{EF2C6A39-79AC-41A7-B36B-21BEB452CCBA}"/>
+                <a16:creationId xmlns:a16="http://schemas.microsoft.com/office/drawing/2014/main" id="{3A0C3F08-3F6F-4A98-81EA-BA1AF14302B2}"/>
               </a:ext>
             </a:extLst>
           </p:cNvPr>
@@ -5782,7 +5782,7 @@
           <p:cNvPr id="10" name="">
             <a:extLst xmlns:a="http://schemas.openxmlformats.org/drawingml/2006/main">
               <a:ext uri="{FF2B5EF4-FFF2-40B4-BE49-F238E27FC236}">
-                <a16:creationId xmlns:a16="http://schemas.microsoft.com/office/drawing/2014/main" id="{19A4E6EF-DFF8-4A70-B44B-D82E6145DB09}"/>
+                <a16:creationId xmlns:a16="http://schemas.microsoft.com/office/drawing/2014/main" id="{EDC441BC-1CB8-4345-B18B-BA35E94AF1AF}"/>
               </a:ext>
             </a:extLst>
           </p:cNvPr>
@@ -5813,7 +5813,7 @@
           <p:cNvPr id="11" name="">
             <a:extLst xmlns:a="http://schemas.openxmlformats.org/drawingml/2006/main">
               <a:ext uri="{FF2B5EF4-FFF2-40B4-BE49-F238E27FC236}">
-                <a16:creationId xmlns:a16="http://schemas.microsoft.com/office/drawing/2014/main" id="{0D515E4A-ED43-4EEE-8B7B-A4D457F9E287}"/>
+                <a16:creationId xmlns:a16="http://schemas.microsoft.com/office/drawing/2014/main" id="{590FB61D-3358-464D-A1D0-145E72DAB674}"/>
               </a:ext>
             </a:extLst>
           </p:cNvPr>
@@ -5882,7 +5882,7 @@
           <p:cNvPr id="12" name="">
             <a:extLst xmlns:a="http://schemas.openxmlformats.org/drawingml/2006/main">
               <a:ext uri="{FF2B5EF4-FFF2-40B4-BE49-F238E27FC236}">
-                <a16:creationId xmlns:a16="http://schemas.microsoft.com/office/drawing/2014/main" id="{EF8D0818-F690-4C68-80BA-B6055EB6E28B}"/>
+                <a16:creationId xmlns:a16="http://schemas.microsoft.com/office/drawing/2014/main" id="{017AAB04-3321-4E89-8D0A-18F39B813BD8}"/>
               </a:ext>
             </a:extLst>
           </p:cNvPr>
@@ -5951,7 +5951,7 @@
           <p:cNvPr id="13" name="">
             <a:extLst xmlns:a="http://schemas.openxmlformats.org/drawingml/2006/main">
               <a:ext uri="{FF2B5EF4-FFF2-40B4-BE49-F238E27FC236}">
-                <a16:creationId xmlns:a16="http://schemas.microsoft.com/office/drawing/2014/main" id="{A5F2F184-C814-4DA3-8B8A-69CAF0B24CE0}"/>
+                <a16:creationId xmlns:a16="http://schemas.microsoft.com/office/drawing/2014/main" id="{9B963CE8-BE4D-4EAE-ACA0-9931A1ADE5F2}"/>
               </a:ext>
             </a:extLst>
           </p:cNvPr>
@@ -6020,7 +6020,7 @@
           <p:cNvPr id="14" name="">
             <a:extLst xmlns:a="http://schemas.openxmlformats.org/drawingml/2006/main">
               <a:ext uri="{FF2B5EF4-FFF2-40B4-BE49-F238E27FC236}">
-                <a16:creationId xmlns:a16="http://schemas.microsoft.com/office/drawing/2014/main" id="{B07098FB-5973-48C2-9BC2-73C7CE0F62A1}"/>
+                <a16:creationId xmlns:a16="http://schemas.microsoft.com/office/drawing/2014/main" id="{F5E7C15B-D270-4E32-B88C-61400A40A5A1}"/>
               </a:ext>
             </a:extLst>
           </p:cNvPr>
@@ -6087,7 +6087,7 @@
     </p:spTree>
     <p:extLst>
       <p:ext uri="{BB962C8B-B14F-4D97-AF65-F5344CB8AC3E}">
-        <p14:creationId xmlns:p14="http://schemas.microsoft.com/office/powerpoint/2010/main" val="1609872158"/>
+        <p14:creationId xmlns:p14="http://schemas.microsoft.com/office/powerpoint/2010/main" val="757492054"/>
       </p:ext>
     </p:extLst>
   </p:cSld>
@@ -6118,7 +6118,7 @@
           <p:cNvPr id="9" name="">
             <a:extLst xmlns:a="http://schemas.openxmlformats.org/drawingml/2006/main">
               <a:ext uri="{FF2B5EF4-FFF2-40B4-BE49-F238E27FC236}">
-                <a16:creationId xmlns:a16="http://schemas.microsoft.com/office/drawing/2014/main" id="{C76FD49D-B108-43DD-8BF2-37289F4BA681}"/>
+                <a16:creationId xmlns:a16="http://schemas.microsoft.com/office/drawing/2014/main" id="{0135FB8F-373B-4ED5-9302-23EA7929D5C8}"/>
               </a:ext>
             </a:extLst>
           </p:cNvPr>
@@ -6187,7 +6187,7 @@
           <p:cNvPr id="2" name="">
             <a:extLst xmlns:a="http://schemas.openxmlformats.org/drawingml/2006/main">
               <a:ext uri="{FF2B5EF4-FFF2-40B4-BE49-F238E27FC236}">
-                <a16:creationId xmlns:a16="http://schemas.microsoft.com/office/drawing/2014/main" id="{9F3CBEF1-B124-4C4C-BECD-5403BD7395D4}"/>
+                <a16:creationId xmlns:a16="http://schemas.microsoft.com/office/drawing/2014/main" id="{E627235A-6539-4694-9719-61E50F7C45E0}"/>
               </a:ext>
             </a:extLst>
           </p:cNvPr>
@@ -6218,7 +6218,7 @@
           <p:cNvPr id="3" name="">
             <a:extLst xmlns:a="http://schemas.openxmlformats.org/drawingml/2006/main">
               <a:ext uri="{FF2B5EF4-FFF2-40B4-BE49-F238E27FC236}">
-                <a16:creationId xmlns:a16="http://schemas.microsoft.com/office/drawing/2014/main" id="{92DD8167-D441-4A91-B8B5-C2178DAA6DFF}"/>
+                <a16:creationId xmlns:a16="http://schemas.microsoft.com/office/drawing/2014/main" id="{7012BA38-9EB5-434C-A23B-3897415D503E}"/>
               </a:ext>
             </a:extLst>
           </p:cNvPr>
@@ -6287,7 +6287,7 @@
           <p:cNvPr id="4" name="">
             <a:extLst xmlns:a="http://schemas.openxmlformats.org/drawingml/2006/main">
               <a:ext uri="{FF2B5EF4-FFF2-40B4-BE49-F238E27FC236}">
-                <a16:creationId xmlns:a16="http://schemas.microsoft.com/office/drawing/2014/main" id="{CCB95662-8B2C-4208-9CA0-7A3D29380A3B}"/>
+                <a16:creationId xmlns:a16="http://schemas.microsoft.com/office/drawing/2014/main" id="{CFD9039C-E8D1-4602-953D-73BE42BA0429}"/>
               </a:ext>
             </a:extLst>
           </p:cNvPr>
@@ -6297,7 +6297,7 @@
           <p:nvPr/>
         </p:nvPicPr>
         <p:blipFill>
-          <a:blip xmlns:r="http://schemas.openxmlformats.org/officeDocument/2006/relationships" xmlns:a="http://schemas.openxmlformats.org/drawingml/2006/main" r:embed="Red154746fb494c86"/>
+          <a:blip xmlns:r="http://schemas.openxmlformats.org/officeDocument/2006/relationships" xmlns:a="http://schemas.openxmlformats.org/drawingml/2006/main" r:embed="Ra7bbcc5e5c4f4eb5"/>
           <a:stretch xmlns:a="http://schemas.openxmlformats.org/drawingml/2006/main"/>
         </p:blipFill>
         <p:spPr>
@@ -6315,7 +6315,7 @@
           <p:cNvPr id="5" name="">
             <a:extLst xmlns:a="http://schemas.openxmlformats.org/drawingml/2006/main">
               <a:ext uri="{FF2B5EF4-FFF2-40B4-BE49-F238E27FC236}">
-                <a16:creationId xmlns:a16="http://schemas.microsoft.com/office/drawing/2014/main" id="{E5C05266-FE96-4848-9D66-95CE3820A804}"/>
+                <a16:creationId xmlns:a16="http://schemas.microsoft.com/office/drawing/2014/main" id="{3F5B3BEC-F4B6-41CC-9B33-4495ED302246}"/>
               </a:ext>
             </a:extLst>
           </p:cNvPr>
@@ -6384,7 +6384,7 @@
           <p:cNvPr id="6" name="">
             <a:extLst xmlns:a="http://schemas.openxmlformats.org/drawingml/2006/main">
               <a:ext uri="{FF2B5EF4-FFF2-40B4-BE49-F238E27FC236}">
-                <a16:creationId xmlns:a16="http://schemas.microsoft.com/office/drawing/2014/main" id="{1D296B9B-04CE-4CD2-B83A-E0D22FB0B5C6}"/>
+                <a16:creationId xmlns:a16="http://schemas.microsoft.com/office/drawing/2014/main" id="{44506A52-D54F-40D3-BFF2-A83393788C00}"/>
               </a:ext>
             </a:extLst>
           </p:cNvPr>
@@ -6522,7 +6522,7 @@
           <p:cNvPr id="7" name="">
             <a:extLst xmlns:a="http://schemas.openxmlformats.org/drawingml/2006/main">
               <a:ext uri="{FF2B5EF4-FFF2-40B4-BE49-F238E27FC236}">
-                <a16:creationId xmlns:a16="http://schemas.microsoft.com/office/drawing/2014/main" id="{7E585FE0-DC9F-4D7D-B21D-02DBA07B8426}"/>
+                <a16:creationId xmlns:a16="http://schemas.microsoft.com/office/drawing/2014/main" id="{AF00FA7E-0987-46FD-8E25-D792E04C5EE3}"/>
               </a:ext>
             </a:extLst>
           </p:cNvPr>
@@ -6553,7 +6553,7 @@
           <p:cNvPr id="8" name="">
             <a:extLst xmlns:a="http://schemas.openxmlformats.org/drawingml/2006/main">
               <a:ext uri="{FF2B5EF4-FFF2-40B4-BE49-F238E27FC236}">
-                <a16:creationId xmlns:a16="http://schemas.microsoft.com/office/drawing/2014/main" id="{BFB607BA-A8F5-406D-BD98-CD779E945811}"/>
+                <a16:creationId xmlns:a16="http://schemas.microsoft.com/office/drawing/2014/main" id="{164387E6-D211-4F6B-97A4-83DC8E10DFEE}"/>
               </a:ext>
             </a:extLst>
           </p:cNvPr>
@@ -6620,7 +6620,7 @@
     </p:spTree>
     <p:extLst>
       <p:ext uri="{BB962C8B-B14F-4D97-AF65-F5344CB8AC3E}">
-        <p14:creationId xmlns:p14="http://schemas.microsoft.com/office/powerpoint/2010/main" val="2046313397"/>
+        <p14:creationId xmlns:p14="http://schemas.microsoft.com/office/powerpoint/2010/main" val="2094516404"/>
       </p:ext>
     </p:extLst>
   </p:cSld>
@@ -6651,7 +6651,7 @@
           <p:cNvPr id="22" name="">
             <a:extLst xmlns:a="http://schemas.openxmlformats.org/drawingml/2006/main">
               <a:ext uri="{FF2B5EF4-FFF2-40B4-BE49-F238E27FC236}">
-                <a16:creationId xmlns:a16="http://schemas.microsoft.com/office/drawing/2014/main" id="{F4BE32EB-EDEB-422C-BFFF-CC777FFD1A82}"/>
+                <a16:creationId xmlns:a16="http://schemas.microsoft.com/office/drawing/2014/main" id="{DE34C43D-4898-4857-BF1E-F23B9EA01477}"/>
               </a:ext>
             </a:extLst>
           </p:cNvPr>
@@ -6720,7 +6720,7 @@
           <p:cNvPr id="2" name="">
             <a:extLst xmlns:a="http://schemas.openxmlformats.org/drawingml/2006/main">
               <a:ext uri="{FF2B5EF4-FFF2-40B4-BE49-F238E27FC236}">
-                <a16:creationId xmlns:a16="http://schemas.microsoft.com/office/drawing/2014/main" id="{C9C46353-30FC-48AA-8CA9-82DEDC94E037}"/>
+                <a16:creationId xmlns:a16="http://schemas.microsoft.com/office/drawing/2014/main" id="{8874DC6F-BB1A-4DA1-B312-9A9B088EB3C6}"/>
               </a:ext>
             </a:extLst>
           </p:cNvPr>
@@ -6751,7 +6751,7 @@
           <p:cNvPr id="3" name="">
             <a:extLst xmlns:a="http://schemas.openxmlformats.org/drawingml/2006/main">
               <a:ext uri="{FF2B5EF4-FFF2-40B4-BE49-F238E27FC236}">
-                <a16:creationId xmlns:a16="http://schemas.microsoft.com/office/drawing/2014/main" id="{2C1E93B1-8A36-4B1B-98CC-4F0D8BE2A247}"/>
+                <a16:creationId xmlns:a16="http://schemas.microsoft.com/office/drawing/2014/main" id="{2FDD6005-39AB-498E-9469-33BBBBA01694}"/>
               </a:ext>
             </a:extLst>
           </p:cNvPr>
@@ -6820,7 +6820,7 @@
           <p:cNvPr id="4" name="">
             <a:extLst xmlns:a="http://schemas.openxmlformats.org/drawingml/2006/main">
               <a:ext uri="{FF2B5EF4-FFF2-40B4-BE49-F238E27FC236}">
-                <a16:creationId xmlns:a16="http://schemas.microsoft.com/office/drawing/2014/main" id="{64DC2C2A-65DB-4326-A07C-431740C971D0}"/>
+                <a16:creationId xmlns:a16="http://schemas.microsoft.com/office/drawing/2014/main" id="{0883151C-36B2-4E1F-9257-3FCF3246AAA7}"/>
               </a:ext>
             </a:extLst>
           </p:cNvPr>
@@ -6889,7 +6889,7 @@
           <p:cNvPr id="5" name="">
             <a:extLst xmlns:a="http://schemas.openxmlformats.org/drawingml/2006/main">
               <a:ext uri="{FF2B5EF4-FFF2-40B4-BE49-F238E27FC236}">
-                <a16:creationId xmlns:a16="http://schemas.microsoft.com/office/drawing/2014/main" id="{49F7038B-ACF3-4FDA-8E6D-9CAA67A0AEFE}"/>
+                <a16:creationId xmlns:a16="http://schemas.microsoft.com/office/drawing/2014/main" id="{5A34A7CC-82B8-4B71-944B-EB4315E6D585}"/>
               </a:ext>
             </a:extLst>
           </p:cNvPr>
@@ -6958,7 +6958,7 @@
           <p:cNvPr id="6" name="">
             <a:extLst xmlns:a="http://schemas.openxmlformats.org/drawingml/2006/main">
               <a:ext uri="{FF2B5EF4-FFF2-40B4-BE49-F238E27FC236}">
-                <a16:creationId xmlns:a16="http://schemas.microsoft.com/office/drawing/2014/main" id="{B6BC496B-4993-489E-907B-3FA94BC4389E}"/>
+                <a16:creationId xmlns:a16="http://schemas.microsoft.com/office/drawing/2014/main" id="{1BAE7CB3-C0FF-4648-B3D1-FD0C8EBC466F}"/>
               </a:ext>
             </a:extLst>
           </p:cNvPr>
@@ -6989,7 +6989,7 @@
           <p:cNvPr id="7" name="">
             <a:extLst xmlns:a="http://schemas.openxmlformats.org/drawingml/2006/main">
               <a:ext uri="{FF2B5EF4-FFF2-40B4-BE49-F238E27FC236}">
-                <a16:creationId xmlns:a16="http://schemas.microsoft.com/office/drawing/2014/main" id="{5C5903BE-3220-419B-9124-7620AC72D555}"/>
+                <a16:creationId xmlns:a16="http://schemas.microsoft.com/office/drawing/2014/main" id="{C5056128-8C8A-48F6-91D5-6A624EAAFB4A}"/>
               </a:ext>
             </a:extLst>
           </p:cNvPr>
@@ -7058,7 +7058,7 @@
           <p:cNvPr id="8" name="">
             <a:extLst xmlns:a="http://schemas.openxmlformats.org/drawingml/2006/main">
               <a:ext uri="{FF2B5EF4-FFF2-40B4-BE49-F238E27FC236}">
-                <a16:creationId xmlns:a16="http://schemas.microsoft.com/office/drawing/2014/main" id="{9B7B74D5-4E43-43D7-BAF2-34983D618F2A}"/>
+                <a16:creationId xmlns:a16="http://schemas.microsoft.com/office/drawing/2014/main" id="{1AE7EC68-FDD5-443B-8BC6-8C15E424FFA8}"/>
               </a:ext>
             </a:extLst>
           </p:cNvPr>
@@ -7127,7 +7127,7 @@
           <p:cNvPr id="9" name="">
             <a:extLst xmlns:a="http://schemas.openxmlformats.org/drawingml/2006/main">
               <a:ext uri="{FF2B5EF4-FFF2-40B4-BE49-F238E27FC236}">
-                <a16:creationId xmlns:a16="http://schemas.microsoft.com/office/drawing/2014/main" id="{878F9CC7-888C-4619-A8A0-47651D4076AC}"/>
+                <a16:creationId xmlns:a16="http://schemas.microsoft.com/office/drawing/2014/main" id="{3BEF7075-97E9-4641-BF90-D7C26CC1823C}"/>
               </a:ext>
             </a:extLst>
           </p:cNvPr>
@@ -7158,7 +7158,7 @@
           <p:cNvPr id="10" name="">
             <a:extLst xmlns:a="http://schemas.openxmlformats.org/drawingml/2006/main">
               <a:ext uri="{FF2B5EF4-FFF2-40B4-BE49-F238E27FC236}">
-                <a16:creationId xmlns:a16="http://schemas.microsoft.com/office/drawing/2014/main" id="{389C62DC-99A3-420A-91B6-9BF8B0D83A95}"/>
+                <a16:creationId xmlns:a16="http://schemas.microsoft.com/office/drawing/2014/main" id="{3E86E6DC-BFE9-427C-AFC4-3795DE8CDD81}"/>
               </a:ext>
             </a:extLst>
           </p:cNvPr>
@@ -7227,7 +7227,7 @@
           <p:cNvPr id="11" name="">
             <a:extLst xmlns:a="http://schemas.openxmlformats.org/drawingml/2006/main">
               <a:ext uri="{FF2B5EF4-FFF2-40B4-BE49-F238E27FC236}">
-                <a16:creationId xmlns:a16="http://schemas.microsoft.com/office/drawing/2014/main" id="{BC2BEFB8-7BAE-4037-9075-C339A131FB1D}"/>
+                <a16:creationId xmlns:a16="http://schemas.microsoft.com/office/drawing/2014/main" id="{EB787447-F7E4-4E45-83BC-D64D734EE7C0}"/>
               </a:ext>
             </a:extLst>
           </p:cNvPr>
@@ -7296,7 +7296,7 @@
           <p:cNvPr id="12" name="">
             <a:extLst xmlns:a="http://schemas.openxmlformats.org/drawingml/2006/main">
               <a:ext uri="{FF2B5EF4-FFF2-40B4-BE49-F238E27FC236}">
-                <a16:creationId xmlns:a16="http://schemas.microsoft.com/office/drawing/2014/main" id="{344711EB-736D-4BAF-9BA8-EBBE7F642616}"/>
+                <a16:creationId xmlns:a16="http://schemas.microsoft.com/office/drawing/2014/main" id="{358B7128-31FD-4D1E-98E6-F1029AAF4762}"/>
               </a:ext>
             </a:extLst>
           </p:cNvPr>
@@ -7327,7 +7327,7 @@
           <p:cNvPr id="13" name="">
             <a:extLst xmlns:a="http://schemas.openxmlformats.org/drawingml/2006/main">
               <a:ext uri="{FF2B5EF4-FFF2-40B4-BE49-F238E27FC236}">
-                <a16:creationId xmlns:a16="http://schemas.microsoft.com/office/drawing/2014/main" id="{B4CE5048-A75C-46A2-B765-FB8038173348}"/>
+                <a16:creationId xmlns:a16="http://schemas.microsoft.com/office/drawing/2014/main" id="{0FF4A0B7-DAB5-4DAB-92B5-ACDDE5C0ED08}"/>
               </a:ext>
             </a:extLst>
           </p:cNvPr>
@@ -7396,7 +7396,7 @@
           <p:cNvPr id="14" name="">
             <a:extLst xmlns:a="http://schemas.openxmlformats.org/drawingml/2006/main">
               <a:ext uri="{FF2B5EF4-FFF2-40B4-BE49-F238E27FC236}">
-                <a16:creationId xmlns:a16="http://schemas.microsoft.com/office/drawing/2014/main" id="{60802381-2D93-4056-95BB-E0F48DEBCC24}"/>
+                <a16:creationId xmlns:a16="http://schemas.microsoft.com/office/drawing/2014/main" id="{1125F3F7-601F-4C94-A7D1-B3EFD32FE400}"/>
               </a:ext>
             </a:extLst>
           </p:cNvPr>
@@ -7465,7 +7465,7 @@
           <p:cNvPr id="15" name="">
             <a:extLst xmlns:a="http://schemas.openxmlformats.org/drawingml/2006/main">
               <a:ext uri="{FF2B5EF4-FFF2-40B4-BE49-F238E27FC236}">
-                <a16:creationId xmlns:a16="http://schemas.microsoft.com/office/drawing/2014/main" id="{25C58267-423E-46E2-BCA5-9B5ACAFBD8D3}"/>
+                <a16:creationId xmlns:a16="http://schemas.microsoft.com/office/drawing/2014/main" id="{486106F6-3FE8-4D44-89F6-72CAA0B26926}"/>
               </a:ext>
             </a:extLst>
           </p:cNvPr>
@@ -7496,7 +7496,7 @@
           <p:cNvPr id="16" name="">
             <a:extLst xmlns:a="http://schemas.openxmlformats.org/drawingml/2006/main">
               <a:ext uri="{FF2B5EF4-FFF2-40B4-BE49-F238E27FC236}">
-                <a16:creationId xmlns:a16="http://schemas.microsoft.com/office/drawing/2014/main" id="{645FEB11-B59F-46E6-89EE-B13ABF8F2A03}"/>
+                <a16:creationId xmlns:a16="http://schemas.microsoft.com/office/drawing/2014/main" id="{C52CB4CE-DC96-4625-BB01-122A5E1D9D2B}"/>
               </a:ext>
             </a:extLst>
           </p:cNvPr>
@@ -7565,7 +7565,7 @@
           <p:cNvPr id="17" name="">
             <a:extLst xmlns:a="http://schemas.openxmlformats.org/drawingml/2006/main">
               <a:ext uri="{FF2B5EF4-FFF2-40B4-BE49-F238E27FC236}">
-                <a16:creationId xmlns:a16="http://schemas.microsoft.com/office/drawing/2014/main" id="{22E225D4-1687-4209-BC9D-C262814CA3C0}"/>
+                <a16:creationId xmlns:a16="http://schemas.microsoft.com/office/drawing/2014/main" id="{D2D06986-D9F3-42E8-A33E-067936EC5A7B}"/>
               </a:ext>
             </a:extLst>
           </p:cNvPr>
@@ -7634,7 +7634,7 @@
           <p:cNvPr id="18" name="">
             <a:extLst xmlns:a="http://schemas.openxmlformats.org/drawingml/2006/main">
               <a:ext uri="{FF2B5EF4-FFF2-40B4-BE49-F238E27FC236}">
-                <a16:creationId xmlns:a16="http://schemas.microsoft.com/office/drawing/2014/main" id="{32EEEE17-7C9E-4112-A984-FF31550DBFF4}"/>
+                <a16:creationId xmlns:a16="http://schemas.microsoft.com/office/drawing/2014/main" id="{469FD60B-7ADC-419A-833E-E0ACCA83AF3B}"/>
               </a:ext>
             </a:extLst>
           </p:cNvPr>
@@ -7667,7 +7667,7 @@
           <p:cNvPr id="19" name="">
             <a:extLst xmlns:a="http://schemas.openxmlformats.org/drawingml/2006/main">
               <a:ext uri="{FF2B5EF4-FFF2-40B4-BE49-F238E27FC236}">
-                <a16:creationId xmlns:a16="http://schemas.microsoft.com/office/drawing/2014/main" id="{DE88B672-9EA8-4B8D-A2D9-8AB8977CFBFF}"/>
+                <a16:creationId xmlns:a16="http://schemas.microsoft.com/office/drawing/2014/main" id="{5BB4DB22-F337-41C5-BDDD-D961D2789CE1}"/>
               </a:ext>
             </a:extLst>
           </p:cNvPr>
@@ -7736,7 +7736,7 @@
           <p:cNvPr id="20" name="">
             <a:extLst xmlns:a="http://schemas.openxmlformats.org/drawingml/2006/main">
               <a:ext uri="{FF2B5EF4-FFF2-40B4-BE49-F238E27FC236}">
-                <a16:creationId xmlns:a16="http://schemas.microsoft.com/office/drawing/2014/main" id="{273EEAD4-4B21-4249-9305-C6DF97A919C2}"/>
+                <a16:creationId xmlns:a16="http://schemas.microsoft.com/office/drawing/2014/main" id="{69858D41-42C2-48F9-AC7D-0335BDC90CFA}"/>
               </a:ext>
             </a:extLst>
           </p:cNvPr>
@@ -7833,7 +7833,7 @@
           <p:cNvPr id="21" name="">
             <a:extLst xmlns:a="http://schemas.openxmlformats.org/drawingml/2006/main">
               <a:ext uri="{FF2B5EF4-FFF2-40B4-BE49-F238E27FC236}">
-                <a16:creationId xmlns:a16="http://schemas.microsoft.com/office/drawing/2014/main" id="{9D2F5C6C-CDE3-471F-9A26-AD4DDCB39306}"/>
+                <a16:creationId xmlns:a16="http://schemas.microsoft.com/office/drawing/2014/main" id="{ED291B75-DABB-4057-8C33-55A5C3FAA370}"/>
               </a:ext>
             </a:extLst>
           </p:cNvPr>
@@ -7892,7 +7892,7 @@
                 <a:ea typeface="Arial"/>
                 <a:cs typeface="Arial"/>
               </a:rPr>
-              <a:t>Test set: 2,212 records</a:t>
+              <a:t>Test set: 2,196 records</a:t>
             </a:r>
           </a:p>
         </p:txBody>
@@ -7900,7 +7900,7 @@
     </p:spTree>
     <p:extLst>
       <p:ext uri="{BB962C8B-B14F-4D97-AF65-F5344CB8AC3E}">
-        <p14:creationId xmlns:p14="http://schemas.microsoft.com/office/powerpoint/2010/main" val="87681350"/>
+        <p14:creationId xmlns:p14="http://schemas.microsoft.com/office/powerpoint/2010/main" val="657886957"/>
       </p:ext>
     </p:extLst>
   </p:cSld>
@@ -7931,7 +7931,7 @@
           <p:cNvPr id="11" name="">
             <a:extLst xmlns:a="http://schemas.openxmlformats.org/drawingml/2006/main">
               <a:ext uri="{FF2B5EF4-FFF2-40B4-BE49-F238E27FC236}">
-                <a16:creationId xmlns:a16="http://schemas.microsoft.com/office/drawing/2014/main" id="{57EEEEEF-9971-420F-BB1A-D0E666822CAF}"/>
+                <a16:creationId xmlns:a16="http://schemas.microsoft.com/office/drawing/2014/main" id="{8B3F6CF0-9CEF-40F6-8466-C1ACCEED42FD}"/>
               </a:ext>
             </a:extLst>
           </p:cNvPr>
@@ -8000,7 +8000,7 @@
           <p:cNvPr id="2" name="">
             <a:extLst xmlns:a="http://schemas.openxmlformats.org/drawingml/2006/main">
               <a:ext uri="{FF2B5EF4-FFF2-40B4-BE49-F238E27FC236}">
-                <a16:creationId xmlns:a16="http://schemas.microsoft.com/office/drawing/2014/main" id="{7288D5F4-94E4-4F70-9D09-C8002F7F53E0}"/>
+                <a16:creationId xmlns:a16="http://schemas.microsoft.com/office/drawing/2014/main" id="{E85C4173-01B8-4946-B43A-A92BF7314CD6}"/>
               </a:ext>
             </a:extLst>
           </p:cNvPr>
@@ -8031,7 +8031,7 @@
           <p:cNvPr id="3" name="">
             <a:extLst xmlns:a="http://schemas.openxmlformats.org/drawingml/2006/main">
               <a:ext uri="{FF2B5EF4-FFF2-40B4-BE49-F238E27FC236}">
-                <a16:creationId xmlns:a16="http://schemas.microsoft.com/office/drawing/2014/main" id="{58AE63B8-8928-4E4D-A3B7-5119F7F3F597}"/>
+                <a16:creationId xmlns:a16="http://schemas.microsoft.com/office/drawing/2014/main" id="{2B56CA2A-79F9-4267-8936-BB0891B15AF3}"/>
               </a:ext>
             </a:extLst>
           </p:cNvPr>
@@ -8100,7 +8100,7 @@
           <p:cNvPr id="4" name="">
             <a:extLst xmlns:a="http://schemas.openxmlformats.org/drawingml/2006/main">
               <a:ext uri="{FF2B5EF4-FFF2-40B4-BE49-F238E27FC236}">
-                <a16:creationId xmlns:a16="http://schemas.microsoft.com/office/drawing/2014/main" id="{94F80664-8A95-4FC3-AA93-B70E2D4951D3}"/>
+                <a16:creationId xmlns:a16="http://schemas.microsoft.com/office/drawing/2014/main" id="{6F81CE62-7EFA-4D75-A218-3D9D0D541857}"/>
               </a:ext>
             </a:extLst>
           </p:cNvPr>
@@ -8169,7 +8169,7 @@
           <p:cNvPr id="5" name="">
             <a:extLst xmlns:a="http://schemas.openxmlformats.org/drawingml/2006/main">
               <a:ext uri="{FF2B5EF4-FFF2-40B4-BE49-F238E27FC236}">
-                <a16:creationId xmlns:a16="http://schemas.microsoft.com/office/drawing/2014/main" id="{FD70679E-CA0A-48D5-A593-E1F326248889}"/>
+                <a16:creationId xmlns:a16="http://schemas.microsoft.com/office/drawing/2014/main" id="{B1441432-7316-48F9-9CFA-C1F298F5FCEC}"/>
               </a:ext>
             </a:extLst>
           </p:cNvPr>
@@ -8284,7 +8284,7 @@
           <p:cNvPr id="6" name="">
             <a:extLst xmlns:a="http://schemas.openxmlformats.org/drawingml/2006/main">
               <a:ext uri="{FF2B5EF4-FFF2-40B4-BE49-F238E27FC236}">
-                <a16:creationId xmlns:a16="http://schemas.microsoft.com/office/drawing/2014/main" id="{D02B9CB6-8A8E-4B9A-BBEB-B7B0E120AFDA}"/>
+                <a16:creationId xmlns:a16="http://schemas.microsoft.com/office/drawing/2014/main" id="{939B9D4E-C6A1-4E40-A3C9-520F79C488E8}"/>
               </a:ext>
             </a:extLst>
           </p:cNvPr>
@@ -8353,7 +8353,7 @@
           <p:cNvPr id="7" name="">
             <a:extLst xmlns:a="http://schemas.openxmlformats.org/drawingml/2006/main">
               <a:ext uri="{FF2B5EF4-FFF2-40B4-BE49-F238E27FC236}">
-                <a16:creationId xmlns:a16="http://schemas.microsoft.com/office/drawing/2014/main" id="{C54519BE-C5A3-42E5-B1C4-D3343FCF234B}"/>
+                <a16:creationId xmlns:a16="http://schemas.microsoft.com/office/drawing/2014/main" id="{1D867EF8-49A7-427E-A91B-9A79484905F2}"/>
               </a:ext>
             </a:extLst>
           </p:cNvPr>
@@ -8468,7 +8468,7 @@
           <p:cNvPr id="8" name="">
             <a:extLst xmlns:a="http://schemas.openxmlformats.org/drawingml/2006/main">
               <a:ext uri="{FF2B5EF4-FFF2-40B4-BE49-F238E27FC236}">
-                <a16:creationId xmlns:a16="http://schemas.microsoft.com/office/drawing/2014/main" id="{19C83C22-922D-4C4F-AF12-4660B2E59BE5}"/>
+                <a16:creationId xmlns:a16="http://schemas.microsoft.com/office/drawing/2014/main" id="{2AE7CA90-C514-4E1B-B1DB-D077E767C447}"/>
               </a:ext>
             </a:extLst>
           </p:cNvPr>
@@ -8499,7 +8499,7 @@
           <p:cNvPr id="9" name="">
             <a:extLst xmlns:a="http://schemas.openxmlformats.org/drawingml/2006/main">
               <a:ext uri="{FF2B5EF4-FFF2-40B4-BE49-F238E27FC236}">
-                <a16:creationId xmlns:a16="http://schemas.microsoft.com/office/drawing/2014/main" id="{FC31E5AB-F6A5-427E-A66C-A2A62A39561C}"/>
+                <a16:creationId xmlns:a16="http://schemas.microsoft.com/office/drawing/2014/main" id="{163595A9-47AE-488D-8994-174803B0B852}"/>
               </a:ext>
             </a:extLst>
           </p:cNvPr>
@@ -8530,7 +8530,7 @@
           <p:cNvPr id="10" name="">
             <a:extLst xmlns:a="http://schemas.openxmlformats.org/drawingml/2006/main">
               <a:ext uri="{FF2B5EF4-FFF2-40B4-BE49-F238E27FC236}">
-                <a16:creationId xmlns:a16="http://schemas.microsoft.com/office/drawing/2014/main" id="{2EB11603-0886-44B4-AC6B-E13817AF5B19}"/>
+                <a16:creationId xmlns:a16="http://schemas.microsoft.com/office/drawing/2014/main" id="{8F58ADC8-927C-47A4-8583-9004DFE00798}"/>
               </a:ext>
             </a:extLst>
           </p:cNvPr>
@@ -8597,7 +8597,7 @@
     </p:spTree>
     <p:extLst>
       <p:ext uri="{BB962C8B-B14F-4D97-AF65-F5344CB8AC3E}">
-        <p14:creationId xmlns:p14="http://schemas.microsoft.com/office/powerpoint/2010/main" val="273486552"/>
+        <p14:creationId xmlns:p14="http://schemas.microsoft.com/office/powerpoint/2010/main" val="570692339"/>
       </p:ext>
     </p:extLst>
   </p:cSld>
@@ -8628,7 +8628,7 @@
           <p:cNvPr id="32" name="">
             <a:extLst xmlns:a="http://schemas.openxmlformats.org/drawingml/2006/main">
               <a:ext uri="{FF2B5EF4-FFF2-40B4-BE49-F238E27FC236}">
-                <a16:creationId xmlns:a16="http://schemas.microsoft.com/office/drawing/2014/main" id="{0620B3DD-C239-42CC-98B3-71D042435612}"/>
+                <a16:creationId xmlns:a16="http://schemas.microsoft.com/office/drawing/2014/main" id="{451A7223-CC7A-4CC3-987A-9A7BACECB7E5}"/>
               </a:ext>
             </a:extLst>
           </p:cNvPr>
@@ -8697,7 +8697,7 @@
           <p:cNvPr id="2" name="">
             <a:extLst xmlns:a="http://schemas.openxmlformats.org/drawingml/2006/main">
               <a:ext uri="{FF2B5EF4-FFF2-40B4-BE49-F238E27FC236}">
-                <a16:creationId xmlns:a16="http://schemas.microsoft.com/office/drawing/2014/main" id="{AA0E21FB-CEFD-417B-BBDF-170DBB2AAD33}"/>
+                <a16:creationId xmlns:a16="http://schemas.microsoft.com/office/drawing/2014/main" id="{551D1E33-0ABE-45DB-B06A-4CFB3A77D9EB}"/>
               </a:ext>
             </a:extLst>
           </p:cNvPr>
@@ -8728,7 +8728,7 @@
           <p:cNvPr id="3" name="">
             <a:extLst xmlns:a="http://schemas.openxmlformats.org/drawingml/2006/main">
               <a:ext uri="{FF2B5EF4-FFF2-40B4-BE49-F238E27FC236}">
-                <a16:creationId xmlns:a16="http://schemas.microsoft.com/office/drawing/2014/main" id="{BA30292B-3255-4A0C-AD59-8514FAA09D97}"/>
+                <a16:creationId xmlns:a16="http://schemas.microsoft.com/office/drawing/2014/main" id="{536EA018-F4E4-4471-B079-DC837233F4E0}"/>
               </a:ext>
             </a:extLst>
           </p:cNvPr>
@@ -8797,7 +8797,7 @@
           <p:cNvPr id="4" name="">
             <a:extLst xmlns:a="http://schemas.openxmlformats.org/drawingml/2006/main">
               <a:ext uri="{FF2B5EF4-FFF2-40B4-BE49-F238E27FC236}">
-                <a16:creationId xmlns:a16="http://schemas.microsoft.com/office/drawing/2014/main" id="{63B52284-580B-414C-988B-F4B6C06D2C3F}"/>
+                <a16:creationId xmlns:a16="http://schemas.microsoft.com/office/drawing/2014/main" id="{4BF8933B-DEE5-4FCA-9AE2-D4BAF15A5F06}"/>
               </a:ext>
             </a:extLst>
           </p:cNvPr>
@@ -8807,13 +8807,13 @@
           <p:nvPr/>
         </p:nvPicPr>
         <p:blipFill>
-          <a:blip xmlns:r="http://schemas.openxmlformats.org/officeDocument/2006/relationships" xmlns:a="http://schemas.openxmlformats.org/drawingml/2006/main" r:embed="R9036f46aa5894ccb"/>
+          <a:blip xmlns:r="http://schemas.openxmlformats.org/officeDocument/2006/relationships" xmlns:a="http://schemas.openxmlformats.org/drawingml/2006/main" r:embed="Re575982c3a8c4cc8"/>
           <a:stretch xmlns:a="http://schemas.openxmlformats.org/drawingml/2006/main"/>
         </p:blipFill>
         <p:spPr>
           <a:xfrm xmlns:a="http://schemas.openxmlformats.org/drawingml/2006/main">
-            <a:off x="647700" y="2050457"/>
-            <a:ext cx="5429250" cy="2280837"/>
+            <a:off x="647700" y="2048681"/>
+            <a:ext cx="5429250" cy="2284388"/>
           </a:xfrm>
           <a:prstGeom xmlns:a="http://schemas.openxmlformats.org/drawingml/2006/main" prst="rect">
             <a:avLst/>
@@ -8825,7 +8825,7 @@
           <p:cNvPr id="5" name="">
             <a:extLst xmlns:a="http://schemas.openxmlformats.org/drawingml/2006/main">
               <a:ext uri="{FF2B5EF4-FFF2-40B4-BE49-F238E27FC236}">
-                <a16:creationId xmlns:a16="http://schemas.microsoft.com/office/drawing/2014/main" id="{23EE4E58-252D-48A2-95CA-7B8BE4DB16F4}"/>
+                <a16:creationId xmlns:a16="http://schemas.microsoft.com/office/drawing/2014/main" id="{0AD07C9A-36DE-412A-9AE5-177C6DEE6B11}"/>
               </a:ext>
             </a:extLst>
           </p:cNvPr>
@@ -8894,7 +8894,7 @@
           <p:cNvPr id="6" name="">
             <a:extLst xmlns:a="http://schemas.openxmlformats.org/drawingml/2006/main">
               <a:ext uri="{FF2B5EF4-FFF2-40B4-BE49-F238E27FC236}">
-                <a16:creationId xmlns:a16="http://schemas.microsoft.com/office/drawing/2014/main" id="{0150A4F2-BAF1-4553-B981-636C0568E09B}"/>
+                <a16:creationId xmlns:a16="http://schemas.microsoft.com/office/drawing/2014/main" id="{E67162A6-0FA3-4AE3-8547-C6D9E5B22D4F}"/>
               </a:ext>
             </a:extLst>
           </p:cNvPr>
@@ -8963,7 +8963,7 @@
           <p:cNvPr id="7" name="">
             <a:extLst xmlns:a="http://schemas.openxmlformats.org/drawingml/2006/main">
               <a:ext uri="{FF2B5EF4-FFF2-40B4-BE49-F238E27FC236}">
-                <a16:creationId xmlns:a16="http://schemas.microsoft.com/office/drawing/2014/main" id="{05EC487F-7B12-4F7E-8149-0DD86E764E89}"/>
+                <a16:creationId xmlns:a16="http://schemas.microsoft.com/office/drawing/2014/main" id="{5C99138A-986B-4384-881A-238FFC49A7BE}"/>
               </a:ext>
             </a:extLst>
           </p:cNvPr>
@@ -9032,7 +9032,7 @@
           <p:cNvPr id="8" name="">
             <a:extLst xmlns:a="http://schemas.openxmlformats.org/drawingml/2006/main">
               <a:ext uri="{FF2B5EF4-FFF2-40B4-BE49-F238E27FC236}">
-                <a16:creationId xmlns:a16="http://schemas.microsoft.com/office/drawing/2014/main" id="{F10D7169-ED44-4CC6-A7AF-B5CBFF048F5D}"/>
+                <a16:creationId xmlns:a16="http://schemas.microsoft.com/office/drawing/2014/main" id="{5A46EFC4-8708-43B7-B0B5-EBE62C61A8FD}"/>
               </a:ext>
             </a:extLst>
           </p:cNvPr>
@@ -9063,7 +9063,7 @@
           <p:cNvPr id="9" name="">
             <a:extLst xmlns:a="http://schemas.openxmlformats.org/drawingml/2006/main">
               <a:ext uri="{FF2B5EF4-FFF2-40B4-BE49-F238E27FC236}">
-                <a16:creationId xmlns:a16="http://schemas.microsoft.com/office/drawing/2014/main" id="{9CC587B4-0864-4165-9D88-DD0D3FB402D2}"/>
+                <a16:creationId xmlns:a16="http://schemas.microsoft.com/office/drawing/2014/main" id="{68380A07-16C9-41D9-9FF8-3F46B1E2EB3D}"/>
               </a:ext>
             </a:extLst>
           </p:cNvPr>
@@ -9132,7 +9132,7 @@
           <p:cNvPr id="10" name="">
             <a:extLst xmlns:a="http://schemas.openxmlformats.org/drawingml/2006/main">
               <a:ext uri="{FF2B5EF4-FFF2-40B4-BE49-F238E27FC236}">
-                <a16:creationId xmlns:a16="http://schemas.microsoft.com/office/drawing/2014/main" id="{96F6BC36-67FC-469A-8A43-F85F566C5E38}"/>
+                <a16:creationId xmlns:a16="http://schemas.microsoft.com/office/drawing/2014/main" id="{668F025C-615C-4218-B5C7-499552186B8C}"/>
               </a:ext>
             </a:extLst>
           </p:cNvPr>
@@ -9191,7 +9191,7 @@
                 <a:ea typeface="Arial"/>
                 <a:cs typeface="Arial"/>
               </a:rPr>
-              <a:t>0.921</a:t>
+              <a:t>0.922</a:t>
             </a:r>
           </a:p>
         </p:txBody>
@@ -9201,7 +9201,7 @@
           <p:cNvPr id="11" name="">
             <a:extLst xmlns:a="http://schemas.openxmlformats.org/drawingml/2006/main">
               <a:ext uri="{FF2B5EF4-FFF2-40B4-BE49-F238E27FC236}">
-                <a16:creationId xmlns:a16="http://schemas.microsoft.com/office/drawing/2014/main" id="{83108ABA-87EE-48FB-BBF7-127A4AA4908F}"/>
+                <a16:creationId xmlns:a16="http://schemas.microsoft.com/office/drawing/2014/main" id="{47C9F70B-388C-4E7C-93FD-5601BA264C44}"/>
               </a:ext>
             </a:extLst>
           </p:cNvPr>
@@ -9260,7 +9260,7 @@
                 <a:ea typeface="Arial"/>
                 <a:cs typeface="Arial"/>
               </a:rPr>
-              <a:t>0.952</a:t>
+              <a:t>0.944</a:t>
             </a:r>
           </a:p>
         </p:txBody>
@@ -9270,7 +9270,7 @@
           <p:cNvPr id="12" name="">
             <a:extLst xmlns:a="http://schemas.openxmlformats.org/drawingml/2006/main">
               <a:ext uri="{FF2B5EF4-FFF2-40B4-BE49-F238E27FC236}">
-                <a16:creationId xmlns:a16="http://schemas.microsoft.com/office/drawing/2014/main" id="{7A569783-DC85-4520-BE94-A37EDBCC438D}"/>
+                <a16:creationId xmlns:a16="http://schemas.microsoft.com/office/drawing/2014/main" id="{5C97E3CE-9A88-4092-A196-4E1DA45BC5AE}"/>
               </a:ext>
             </a:extLst>
           </p:cNvPr>
@@ -9301,7 +9301,7 @@
           <p:cNvPr id="13" name="">
             <a:extLst xmlns:a="http://schemas.openxmlformats.org/drawingml/2006/main">
               <a:ext uri="{FF2B5EF4-FFF2-40B4-BE49-F238E27FC236}">
-                <a16:creationId xmlns:a16="http://schemas.microsoft.com/office/drawing/2014/main" id="{99C49DED-2C81-440B-996E-E9F215D8BA98}"/>
+                <a16:creationId xmlns:a16="http://schemas.microsoft.com/office/drawing/2014/main" id="{9220B4FD-3ACE-4D89-998F-ECD7B8DF1EB1}"/>
               </a:ext>
             </a:extLst>
           </p:cNvPr>
@@ -9370,7 +9370,7 @@
           <p:cNvPr id="14" name="">
             <a:extLst xmlns:a="http://schemas.openxmlformats.org/drawingml/2006/main">
               <a:ext uri="{FF2B5EF4-FFF2-40B4-BE49-F238E27FC236}">
-                <a16:creationId xmlns:a16="http://schemas.microsoft.com/office/drawing/2014/main" id="{3B3A8371-79CA-456C-BA19-08D7627C6E35}"/>
+                <a16:creationId xmlns:a16="http://schemas.microsoft.com/office/drawing/2014/main" id="{6480D263-9E50-47D5-9D8F-893D029069FC}"/>
               </a:ext>
             </a:extLst>
           </p:cNvPr>
@@ -9429,7 +9429,7 @@
                 <a:ea typeface="Arial"/>
                 <a:cs typeface="Arial"/>
               </a:rPr>
-              <a:t>0.921</a:t>
+              <a:t>0.900</a:t>
             </a:r>
           </a:p>
         </p:txBody>
@@ -9439,7 +9439,7 @@
           <p:cNvPr id="15" name="">
             <a:extLst xmlns:a="http://schemas.openxmlformats.org/drawingml/2006/main">
               <a:ext uri="{FF2B5EF4-FFF2-40B4-BE49-F238E27FC236}">
-                <a16:creationId xmlns:a16="http://schemas.microsoft.com/office/drawing/2014/main" id="{5D8A53DF-563C-4655-9290-1F2227941516}"/>
+                <a16:creationId xmlns:a16="http://schemas.microsoft.com/office/drawing/2014/main" id="{D12E904B-57C5-4440-8FE9-1C63529B5149}"/>
               </a:ext>
             </a:extLst>
           </p:cNvPr>
@@ -9498,7 +9498,7 @@
                 <a:ea typeface="Arial"/>
                 <a:cs typeface="Arial"/>
               </a:rPr>
-              <a:t>0.967</a:t>
+              <a:t>0.939</a:t>
             </a:r>
           </a:p>
         </p:txBody>
@@ -9508,7 +9508,7 @@
           <p:cNvPr id="16" name="">
             <a:extLst xmlns:a="http://schemas.openxmlformats.org/drawingml/2006/main">
               <a:ext uri="{FF2B5EF4-FFF2-40B4-BE49-F238E27FC236}">
-                <a16:creationId xmlns:a16="http://schemas.microsoft.com/office/drawing/2014/main" id="{2E966A52-B827-49E4-BE74-AA5A1528D949}"/>
+                <a16:creationId xmlns:a16="http://schemas.microsoft.com/office/drawing/2014/main" id="{C3E08AC1-D664-4C41-8497-E8CD9BDE3499}"/>
               </a:ext>
             </a:extLst>
           </p:cNvPr>
@@ -9539,7 +9539,7 @@
           <p:cNvPr id="17" name="">
             <a:extLst xmlns:a="http://schemas.openxmlformats.org/drawingml/2006/main">
               <a:ext uri="{FF2B5EF4-FFF2-40B4-BE49-F238E27FC236}">
-                <a16:creationId xmlns:a16="http://schemas.microsoft.com/office/drawing/2014/main" id="{6FC71544-ABBD-459F-8465-5E549EAC7B43}"/>
+                <a16:creationId xmlns:a16="http://schemas.microsoft.com/office/drawing/2014/main" id="{18757D9B-F200-4A6D-A65F-A3ADFF7FE7DB}"/>
               </a:ext>
             </a:extLst>
           </p:cNvPr>
@@ -9608,7 +9608,7 @@
           <p:cNvPr id="18" name="">
             <a:extLst xmlns:a="http://schemas.openxmlformats.org/drawingml/2006/main">
               <a:ext uri="{FF2B5EF4-FFF2-40B4-BE49-F238E27FC236}">
-                <a16:creationId xmlns:a16="http://schemas.microsoft.com/office/drawing/2014/main" id="{9EE8EF62-C1C9-40E9-8CD1-C44E3CFF7A08}"/>
+                <a16:creationId xmlns:a16="http://schemas.microsoft.com/office/drawing/2014/main" id="{03D793E3-93A0-46FB-872F-11B1F2DEEA48}"/>
               </a:ext>
             </a:extLst>
           </p:cNvPr>
@@ -9667,7 +9667,7 @@
                 <a:ea typeface="Arial"/>
                 <a:cs typeface="Arial"/>
               </a:rPr>
-              <a:t>0.899</a:t>
+              <a:t>0.930</a:t>
             </a:r>
           </a:p>
         </p:txBody>
@@ -9677,7 +9677,7 @@
           <p:cNvPr id="19" name="">
             <a:extLst xmlns:a="http://schemas.openxmlformats.org/drawingml/2006/main">
               <a:ext uri="{FF2B5EF4-FFF2-40B4-BE49-F238E27FC236}">
-                <a16:creationId xmlns:a16="http://schemas.microsoft.com/office/drawing/2014/main" id="{A1A4D6D3-F154-4BFD-A6C1-670CF7EAF1EC}"/>
+                <a16:creationId xmlns:a16="http://schemas.microsoft.com/office/drawing/2014/main" id="{7BFEC0EF-2F9D-45DD-BCB0-C9304AB03759}"/>
               </a:ext>
             </a:extLst>
           </p:cNvPr>
@@ -9736,7 +9736,7 @@
                 <a:ea typeface="Arial"/>
                 <a:cs typeface="Arial"/>
               </a:rPr>
-              <a:t>0.923</a:t>
+              <a:t>0.937</a:t>
             </a:r>
           </a:p>
         </p:txBody>
@@ -9746,7 +9746,7 @@
           <p:cNvPr id="20" name="">
             <a:extLst xmlns:a="http://schemas.openxmlformats.org/drawingml/2006/main">
               <a:ext uri="{FF2B5EF4-FFF2-40B4-BE49-F238E27FC236}">
-                <a16:creationId xmlns:a16="http://schemas.microsoft.com/office/drawing/2014/main" id="{F6980A08-C52F-451F-A753-6AC0DD9739EA}"/>
+                <a16:creationId xmlns:a16="http://schemas.microsoft.com/office/drawing/2014/main" id="{AD935EF4-2249-4408-BFD1-E24B82607A9A}"/>
               </a:ext>
             </a:extLst>
           </p:cNvPr>
@@ -9777,7 +9777,7 @@
           <p:cNvPr id="21" name="">
             <a:extLst xmlns:a="http://schemas.openxmlformats.org/drawingml/2006/main">
               <a:ext uri="{FF2B5EF4-FFF2-40B4-BE49-F238E27FC236}">
-                <a16:creationId xmlns:a16="http://schemas.microsoft.com/office/drawing/2014/main" id="{D6B07B04-CF7D-4D54-A824-2BC355B2FB67}"/>
+                <a16:creationId xmlns:a16="http://schemas.microsoft.com/office/drawing/2014/main" id="{1BC519BA-0392-4CB6-9945-85A5779A0C10}"/>
               </a:ext>
             </a:extLst>
           </p:cNvPr>
@@ -9846,7 +9846,7 @@
           <p:cNvPr id="22" name="">
             <a:extLst xmlns:a="http://schemas.openxmlformats.org/drawingml/2006/main">
               <a:ext uri="{FF2B5EF4-FFF2-40B4-BE49-F238E27FC236}">
-                <a16:creationId xmlns:a16="http://schemas.microsoft.com/office/drawing/2014/main" id="{B09E1DE9-D624-4095-8DB5-4E60C8E6FC34}"/>
+                <a16:creationId xmlns:a16="http://schemas.microsoft.com/office/drawing/2014/main" id="{35E0D519-7BED-460A-9747-3118CAFCFB22}"/>
               </a:ext>
             </a:extLst>
           </p:cNvPr>
@@ -9905,7 +9905,7 @@
                 <a:ea typeface="Arial"/>
                 <a:cs typeface="Arial"/>
               </a:rPr>
-              <a:t>0.910</a:t>
+              <a:t>0.915</a:t>
             </a:r>
           </a:p>
         </p:txBody>
@@ -9915,7 +9915,7 @@
           <p:cNvPr id="23" name="">
             <a:extLst xmlns:a="http://schemas.openxmlformats.org/drawingml/2006/main">
               <a:ext uri="{FF2B5EF4-FFF2-40B4-BE49-F238E27FC236}">
-                <a16:creationId xmlns:a16="http://schemas.microsoft.com/office/drawing/2014/main" id="{0A220C15-10DA-4112-B378-AA8584AFBD90}"/>
+                <a16:creationId xmlns:a16="http://schemas.microsoft.com/office/drawing/2014/main" id="{9BC1191F-16EA-4C99-8C5D-58009CF4B9AD}"/>
               </a:ext>
             </a:extLst>
           </p:cNvPr>
@@ -9974,7 +9974,7 @@
                 <a:ea typeface="Arial"/>
                 <a:cs typeface="Arial"/>
               </a:rPr>
-              <a:t>0.945</a:t>
+              <a:t>0.938</a:t>
             </a:r>
           </a:p>
         </p:txBody>
@@ -9984,7 +9984,7 @@
           <p:cNvPr id="24" name="">
             <a:extLst xmlns:a="http://schemas.openxmlformats.org/drawingml/2006/main">
               <a:ext uri="{FF2B5EF4-FFF2-40B4-BE49-F238E27FC236}">
-                <a16:creationId xmlns:a16="http://schemas.microsoft.com/office/drawing/2014/main" id="{864D6A5E-C1D3-4D2E-9049-3A39F8BF21A9}"/>
+                <a16:creationId xmlns:a16="http://schemas.microsoft.com/office/drawing/2014/main" id="{5ACC25F5-B8A0-4EBC-AB35-7581A50EBCDB}"/>
               </a:ext>
             </a:extLst>
           </p:cNvPr>
@@ -10015,7 +10015,7 @@
           <p:cNvPr id="25" name="">
             <a:extLst xmlns:a="http://schemas.openxmlformats.org/drawingml/2006/main">
               <a:ext uri="{FF2B5EF4-FFF2-40B4-BE49-F238E27FC236}">
-                <a16:creationId xmlns:a16="http://schemas.microsoft.com/office/drawing/2014/main" id="{EB81C93F-6BA4-4E7C-9FF8-E40D1582D811}"/>
+                <a16:creationId xmlns:a16="http://schemas.microsoft.com/office/drawing/2014/main" id="{9F645E67-5EA9-40CB-85B3-7B107DDE3D0A}"/>
               </a:ext>
             </a:extLst>
           </p:cNvPr>
@@ -10084,7 +10084,7 @@
           <p:cNvPr id="26" name="">
             <a:extLst xmlns:a="http://schemas.openxmlformats.org/drawingml/2006/main">
               <a:ext uri="{FF2B5EF4-FFF2-40B4-BE49-F238E27FC236}">
-                <a16:creationId xmlns:a16="http://schemas.microsoft.com/office/drawing/2014/main" id="{55DE4CE0-605C-44B9-B1F1-8430742D0EBD}"/>
+                <a16:creationId xmlns:a16="http://schemas.microsoft.com/office/drawing/2014/main" id="{C35CCC77-7777-4B9E-8CDB-D393462666A1}"/>
               </a:ext>
             </a:extLst>
           </p:cNvPr>
@@ -10143,7 +10143,7 @@
                 <a:ea typeface="Arial"/>
                 <a:cs typeface="Arial"/>
               </a:rPr>
-              <a:t>0.979</a:t>
+              <a:t>0.974</a:t>
             </a:r>
           </a:p>
         </p:txBody>
@@ -10153,7 +10153,7 @@
           <p:cNvPr id="27" name="">
             <a:extLst xmlns:a="http://schemas.openxmlformats.org/drawingml/2006/main">
               <a:ext uri="{FF2B5EF4-FFF2-40B4-BE49-F238E27FC236}">
-                <a16:creationId xmlns:a16="http://schemas.microsoft.com/office/drawing/2014/main" id="{94F39FD2-3D66-4D54-BED0-009B5A88FBAD}"/>
+                <a16:creationId xmlns:a16="http://schemas.microsoft.com/office/drawing/2014/main" id="{FF2E81F0-F78F-4572-9E09-9A53D46A98E0}"/>
               </a:ext>
             </a:extLst>
           </p:cNvPr>
@@ -10212,7 +10212,7 @@
                 <a:ea typeface="Arial"/>
                 <a:cs typeface="Arial"/>
               </a:rPr>
-              <a:t>0.992</a:t>
+              <a:t>0.986</a:t>
             </a:r>
           </a:p>
         </p:txBody>
@@ -10222,7 +10222,7 @@
           <p:cNvPr id="28" name="">
             <a:extLst xmlns:a="http://schemas.openxmlformats.org/drawingml/2006/main">
               <a:ext uri="{FF2B5EF4-FFF2-40B4-BE49-F238E27FC236}">
-                <a16:creationId xmlns:a16="http://schemas.microsoft.com/office/drawing/2014/main" id="{071C88A6-2854-4FAD-B47D-11743C5ED5C9}"/>
+                <a16:creationId xmlns:a16="http://schemas.microsoft.com/office/drawing/2014/main" id="{90C28DEC-C300-45ED-879F-21FB757678DC}"/>
               </a:ext>
             </a:extLst>
           </p:cNvPr>
@@ -10253,7 +10253,7 @@
           <p:cNvPr id="29" name="">
             <a:extLst xmlns:a="http://schemas.openxmlformats.org/drawingml/2006/main">
               <a:ext uri="{FF2B5EF4-FFF2-40B4-BE49-F238E27FC236}">
-                <a16:creationId xmlns:a16="http://schemas.microsoft.com/office/drawing/2014/main" id="{A79F42B4-D139-4247-AAD9-313EC933CBBC}"/>
+                <a16:creationId xmlns:a16="http://schemas.microsoft.com/office/drawing/2014/main" id="{79A2C54E-7E10-43A7-973A-9B5EC0E7FAC8}"/>
               </a:ext>
             </a:extLst>
           </p:cNvPr>
@@ -10322,7 +10322,7 @@
           <p:cNvPr id="30" name="">
             <a:extLst xmlns:a="http://schemas.openxmlformats.org/drawingml/2006/main">
               <a:ext uri="{FF2B5EF4-FFF2-40B4-BE49-F238E27FC236}">
-                <a16:creationId xmlns:a16="http://schemas.microsoft.com/office/drawing/2014/main" id="{B6522FC2-5D0C-44FE-BD49-6478CEDB1CF0}"/>
+                <a16:creationId xmlns:a16="http://schemas.microsoft.com/office/drawing/2014/main" id="{B630195E-1FFE-4CF0-A72F-5530DC223142}"/>
               </a:ext>
             </a:extLst>
           </p:cNvPr>
@@ -10381,7 +10381,7 @@
                 <a:ea typeface="Arial"/>
                 <a:cs typeface="Arial"/>
               </a:rPr>
-              <a:t>0.101</a:t>
+              <a:t>0.070</a:t>
             </a:r>
           </a:p>
         </p:txBody>
@@ -10391,7 +10391,7 @@
           <p:cNvPr id="31" name="">
             <a:extLst xmlns:a="http://schemas.openxmlformats.org/drawingml/2006/main">
               <a:ext uri="{FF2B5EF4-FFF2-40B4-BE49-F238E27FC236}">
-                <a16:creationId xmlns:a16="http://schemas.microsoft.com/office/drawing/2014/main" id="{D1A319E2-314C-4AEB-BCEC-8A21D189AC76}"/>
+                <a16:creationId xmlns:a16="http://schemas.microsoft.com/office/drawing/2014/main" id="{DC87ACE6-8F1A-4ED7-90DE-E60C2976227F}"/>
               </a:ext>
             </a:extLst>
           </p:cNvPr>
@@ -10450,7 +10450,7 @@
                 <a:ea typeface="Arial"/>
                 <a:cs typeface="Arial"/>
               </a:rPr>
-              <a:t>0.077</a:t>
+              <a:t>0.063</a:t>
             </a:r>
           </a:p>
         </p:txBody>
@@ -10458,7 +10458,7 @@
     </p:spTree>
     <p:extLst>
       <p:ext uri="{BB962C8B-B14F-4D97-AF65-F5344CB8AC3E}">
-        <p14:creationId xmlns:p14="http://schemas.microsoft.com/office/powerpoint/2010/main" val="1424414594"/>
+        <p14:creationId xmlns:p14="http://schemas.microsoft.com/office/powerpoint/2010/main" val="1102848392"/>
       </p:ext>
     </p:extLst>
   </p:cSld>
@@ -10489,7 +10489,7 @@
           <p:cNvPr id="10" name="">
             <a:extLst xmlns:a="http://schemas.openxmlformats.org/drawingml/2006/main">
               <a:ext uri="{FF2B5EF4-FFF2-40B4-BE49-F238E27FC236}">
-                <a16:creationId xmlns:a16="http://schemas.microsoft.com/office/drawing/2014/main" id="{F8923A3B-F124-465C-A13E-ACDAF988722C}"/>
+                <a16:creationId xmlns:a16="http://schemas.microsoft.com/office/drawing/2014/main" id="{D6DF34C3-D26F-4369-B1FB-594ABB7728BF}"/>
               </a:ext>
             </a:extLst>
           </p:cNvPr>
@@ -10558,7 +10558,7 @@
           <p:cNvPr id="2" name="">
             <a:extLst xmlns:a="http://schemas.openxmlformats.org/drawingml/2006/main">
               <a:ext uri="{FF2B5EF4-FFF2-40B4-BE49-F238E27FC236}">
-                <a16:creationId xmlns:a16="http://schemas.microsoft.com/office/drawing/2014/main" id="{9AD6D381-1333-4867-BAEA-0AB18C09A747}"/>
+                <a16:creationId xmlns:a16="http://schemas.microsoft.com/office/drawing/2014/main" id="{73FA5113-846D-4153-B6F0-9078D018A4BA}"/>
               </a:ext>
             </a:extLst>
           </p:cNvPr>
@@ -10589,7 +10589,7 @@
           <p:cNvPr id="3" name="">
             <a:extLst xmlns:a="http://schemas.openxmlformats.org/drawingml/2006/main">
               <a:ext uri="{FF2B5EF4-FFF2-40B4-BE49-F238E27FC236}">
-                <a16:creationId xmlns:a16="http://schemas.microsoft.com/office/drawing/2014/main" id="{1B414364-B112-4327-826E-4E4BD07838EB}"/>
+                <a16:creationId xmlns:a16="http://schemas.microsoft.com/office/drawing/2014/main" id="{DCE6C87D-DF7B-42D1-ADB9-4BF52D5B1DED}"/>
               </a:ext>
             </a:extLst>
           </p:cNvPr>
@@ -10658,7 +10658,7 @@
           <p:cNvPr id="4" name="">
             <a:extLst xmlns:a="http://schemas.openxmlformats.org/drawingml/2006/main">
               <a:ext uri="{FF2B5EF4-FFF2-40B4-BE49-F238E27FC236}">
-                <a16:creationId xmlns:a16="http://schemas.microsoft.com/office/drawing/2014/main" id="{4BC61F5B-A14B-4789-A665-5D2C56E08719}"/>
+                <a16:creationId xmlns:a16="http://schemas.microsoft.com/office/drawing/2014/main" id="{49042180-42E7-4DB5-BD54-5E73CAF74023}"/>
               </a:ext>
             </a:extLst>
           </p:cNvPr>
@@ -10668,7 +10668,7 @@
           <p:nvPr/>
         </p:nvPicPr>
         <p:blipFill>
-          <a:blip xmlns:r="http://schemas.openxmlformats.org/officeDocument/2006/relationships" xmlns:a="http://schemas.openxmlformats.org/drawingml/2006/main" r:embed="R9567a4973efe4cb9"/>
+          <a:blip xmlns:r="http://schemas.openxmlformats.org/officeDocument/2006/relationships" xmlns:a="http://schemas.openxmlformats.org/drawingml/2006/main" r:embed="Rbf15ba1347bb4bc2"/>
           <a:stretch xmlns:a="http://schemas.openxmlformats.org/drawingml/2006/main"/>
         </p:blipFill>
         <p:spPr>
@@ -10686,7 +10686,7 @@
           <p:cNvPr id="5" name="">
             <a:extLst xmlns:a="http://schemas.openxmlformats.org/drawingml/2006/main">
               <a:ext uri="{FF2B5EF4-FFF2-40B4-BE49-F238E27FC236}">
-                <a16:creationId xmlns:a16="http://schemas.microsoft.com/office/drawing/2014/main" id="{6DDB1FF8-9682-4592-B78C-5EC9A910794A}"/>
+                <a16:creationId xmlns:a16="http://schemas.microsoft.com/office/drawing/2014/main" id="{AF59EEF0-C63E-478B-959B-16BBE2900FDE}"/>
               </a:ext>
             </a:extLst>
           </p:cNvPr>
@@ -10745,7 +10745,7 @@
                 <a:ea typeface="Arial"/>
                 <a:cs typeface="Arial"/>
               </a:rPr>
-              <a:t>75</a:t>
+              <a:t>63</a:t>
             </a:r>
           </a:p>
         </p:txBody>
@@ -10755,7 +10755,7 @@
           <p:cNvPr id="6" name="">
             <a:extLst xmlns:a="http://schemas.openxmlformats.org/drawingml/2006/main">
               <a:ext uri="{FF2B5EF4-FFF2-40B4-BE49-F238E27FC236}">
-                <a16:creationId xmlns:a16="http://schemas.microsoft.com/office/drawing/2014/main" id="{8184F8F5-AFAB-46AD-83DD-352F54CBC3F3}"/>
+                <a16:creationId xmlns:a16="http://schemas.microsoft.com/office/drawing/2014/main" id="{0D50B8DC-E087-45BF-81B2-EA3B88A34BC5}"/>
               </a:ext>
             </a:extLst>
           </p:cNvPr>
@@ -10824,7 +10824,7 @@
           <p:cNvPr id="7" name="">
             <a:extLst xmlns:a="http://schemas.openxmlformats.org/drawingml/2006/main">
               <a:ext uri="{FF2B5EF4-FFF2-40B4-BE49-F238E27FC236}">
-                <a16:creationId xmlns:a16="http://schemas.microsoft.com/office/drawing/2014/main" id="{E9A18B6B-7B1D-454F-A530-78DE5B72FC5C}"/>
+                <a16:creationId xmlns:a16="http://schemas.microsoft.com/office/drawing/2014/main" id="{AEEC136C-4404-4206-A3C9-D55615A3F66E}"/>
               </a:ext>
             </a:extLst>
           </p:cNvPr>
@@ -10883,7 +10883,7 @@
                 <a:ea typeface="Arial"/>
                 <a:cs typeface="Arial"/>
               </a:rPr>
-              <a:t>31</a:t>
+              <a:t>60</a:t>
             </a:r>
           </a:p>
         </p:txBody>
@@ -10893,7 +10893,7 @@
           <p:cNvPr id="8" name="">
             <a:extLst xmlns:a="http://schemas.openxmlformats.org/drawingml/2006/main">
               <a:ext uri="{FF2B5EF4-FFF2-40B4-BE49-F238E27FC236}">
-                <a16:creationId xmlns:a16="http://schemas.microsoft.com/office/drawing/2014/main" id="{90AA84C6-6221-4B5A-B505-B3ACBE74B862}"/>
+                <a16:creationId xmlns:a16="http://schemas.microsoft.com/office/drawing/2014/main" id="{13C52EDD-A3AD-4814-9F48-5FB15173DF2E}"/>
               </a:ext>
             </a:extLst>
           </p:cNvPr>
@@ -10962,7 +10962,7 @@
           <p:cNvPr id="9" name="">
             <a:extLst xmlns:a="http://schemas.openxmlformats.org/drawingml/2006/main">
               <a:ext uri="{FF2B5EF4-FFF2-40B4-BE49-F238E27FC236}">
-                <a16:creationId xmlns:a16="http://schemas.microsoft.com/office/drawing/2014/main" id="{36E217CC-C0EE-4FCB-8F4C-34398143E669}"/>
+                <a16:creationId xmlns:a16="http://schemas.microsoft.com/office/drawing/2014/main" id="{18FB13F1-AD90-46C2-A3DE-2824C6CB5FF1}"/>
               </a:ext>
             </a:extLst>
           </p:cNvPr>
@@ -11029,7 +11029,7 @@
     </p:spTree>
     <p:extLst>
       <p:ext uri="{BB962C8B-B14F-4D97-AF65-F5344CB8AC3E}">
-        <p14:creationId xmlns:p14="http://schemas.microsoft.com/office/powerpoint/2010/main" val="438041533"/>
+        <p14:creationId xmlns:p14="http://schemas.microsoft.com/office/powerpoint/2010/main" val="1563954556"/>
       </p:ext>
     </p:extLst>
   </p:cSld>
@@ -11060,7 +11060,7 @@
           <p:cNvPr id="9" name="">
             <a:extLst xmlns:a="http://schemas.openxmlformats.org/drawingml/2006/main">
               <a:ext uri="{FF2B5EF4-FFF2-40B4-BE49-F238E27FC236}">
-                <a16:creationId xmlns:a16="http://schemas.microsoft.com/office/drawing/2014/main" id="{FC15DC74-22C7-4597-AC71-9477B5598AE0}"/>
+                <a16:creationId xmlns:a16="http://schemas.microsoft.com/office/drawing/2014/main" id="{21782AD4-A522-48F1-950B-E4C48B2C499F}"/>
               </a:ext>
             </a:extLst>
           </p:cNvPr>
@@ -11129,7 +11129,7 @@
           <p:cNvPr id="2" name="">
             <a:extLst xmlns:a="http://schemas.openxmlformats.org/drawingml/2006/main">
               <a:ext uri="{FF2B5EF4-FFF2-40B4-BE49-F238E27FC236}">
-                <a16:creationId xmlns:a16="http://schemas.microsoft.com/office/drawing/2014/main" id="{3A337BB8-6FB2-49D1-9490-07FC1F4EDD05}"/>
+                <a16:creationId xmlns:a16="http://schemas.microsoft.com/office/drawing/2014/main" id="{1C5D2488-7543-4B2A-AF2C-2015266B5370}"/>
               </a:ext>
             </a:extLst>
           </p:cNvPr>
@@ -11160,7 +11160,7 @@
           <p:cNvPr id="3" name="">
             <a:extLst xmlns:a="http://schemas.openxmlformats.org/drawingml/2006/main">
               <a:ext uri="{FF2B5EF4-FFF2-40B4-BE49-F238E27FC236}">
-                <a16:creationId xmlns:a16="http://schemas.microsoft.com/office/drawing/2014/main" id="{D6AF1E27-A988-4BC8-B4E7-5B75CA4581B5}"/>
+                <a16:creationId xmlns:a16="http://schemas.microsoft.com/office/drawing/2014/main" id="{66851F9E-FA10-4912-BACB-E58ACF4107B5}"/>
               </a:ext>
             </a:extLst>
           </p:cNvPr>
@@ -11229,7 +11229,7 @@
           <p:cNvPr id="4" name="">
             <a:extLst xmlns:a="http://schemas.openxmlformats.org/drawingml/2006/main">
               <a:ext uri="{FF2B5EF4-FFF2-40B4-BE49-F238E27FC236}">
-                <a16:creationId xmlns:a16="http://schemas.microsoft.com/office/drawing/2014/main" id="{0F73B0AE-803F-4764-AE88-5D965B9E7E2C}"/>
+                <a16:creationId xmlns:a16="http://schemas.microsoft.com/office/drawing/2014/main" id="{5693256E-15BD-4D2C-A2EB-A00CE07BB17C}"/>
               </a:ext>
             </a:extLst>
           </p:cNvPr>
@@ -11239,13 +11239,13 @@
           <p:nvPr/>
         </p:nvPicPr>
         <p:blipFill>
-          <a:blip xmlns:r="http://schemas.openxmlformats.org/officeDocument/2006/relationships" xmlns:a="http://schemas.openxmlformats.org/drawingml/2006/main" r:embed="R91ce712c17c64f93"/>
+          <a:blip xmlns:r="http://schemas.openxmlformats.org/officeDocument/2006/relationships" xmlns:a="http://schemas.openxmlformats.org/drawingml/2006/main" r:embed="Rc3c5c1b5175d48a4"/>
           <a:stretch xmlns:a="http://schemas.openxmlformats.org/drawingml/2006/main"/>
         </p:blipFill>
         <p:spPr>
           <a:xfrm xmlns:a="http://schemas.openxmlformats.org/drawingml/2006/main">
-            <a:off x="768938" y="1381125"/>
-            <a:ext cx="5701124" cy="3810000"/>
+            <a:off x="826291" y="1381125"/>
+            <a:ext cx="5586417" cy="3810000"/>
           </a:xfrm>
           <a:prstGeom xmlns:a="http://schemas.openxmlformats.org/drawingml/2006/main" prst="rect">
             <a:avLst/>
@@ -11257,7 +11257,7 @@
           <p:cNvPr id="5" name="">
             <a:extLst xmlns:a="http://schemas.openxmlformats.org/drawingml/2006/main">
               <a:ext uri="{FF2B5EF4-FFF2-40B4-BE49-F238E27FC236}">
-                <a16:creationId xmlns:a16="http://schemas.microsoft.com/office/drawing/2014/main" id="{C23D9AEE-A2F4-4626-95C3-81D33FCBF2A1}"/>
+                <a16:creationId xmlns:a16="http://schemas.microsoft.com/office/drawing/2014/main" id="{3214B4DD-E486-4C72-90D7-39059A1727C7}"/>
               </a:ext>
             </a:extLst>
           </p:cNvPr>
@@ -11326,7 +11326,7 @@
           <p:cNvPr id="6" name="">
             <a:extLst xmlns:a="http://schemas.openxmlformats.org/drawingml/2006/main">
               <a:ext uri="{FF2B5EF4-FFF2-40B4-BE49-F238E27FC236}">
-                <a16:creationId xmlns:a16="http://schemas.microsoft.com/office/drawing/2014/main" id="{DABDD271-4DF2-419D-AA1D-025080FDBC38}"/>
+                <a16:creationId xmlns:a16="http://schemas.microsoft.com/office/drawing/2014/main" id="{0D981B58-B2CA-42AE-93C5-8DD97EC843A7}"/>
               </a:ext>
             </a:extLst>
           </p:cNvPr>
@@ -11510,7 +11510,7 @@
           <p:cNvPr id="7" name="">
             <a:extLst xmlns:a="http://schemas.openxmlformats.org/drawingml/2006/main">
               <a:ext uri="{FF2B5EF4-FFF2-40B4-BE49-F238E27FC236}">
-                <a16:creationId xmlns:a16="http://schemas.microsoft.com/office/drawing/2014/main" id="{56E50F16-DCA3-420D-984D-8E1AB88D588D}"/>
+                <a16:creationId xmlns:a16="http://schemas.microsoft.com/office/drawing/2014/main" id="{40E4C92E-1A44-45AE-80D2-E2355D0610F0}"/>
               </a:ext>
             </a:extLst>
           </p:cNvPr>
@@ -11541,7 +11541,7 @@
           <p:cNvPr id="8" name="">
             <a:extLst xmlns:a="http://schemas.openxmlformats.org/drawingml/2006/main">
               <a:ext uri="{FF2B5EF4-FFF2-40B4-BE49-F238E27FC236}">
-                <a16:creationId xmlns:a16="http://schemas.microsoft.com/office/drawing/2014/main" id="{5A895086-8C38-432D-9A54-1110C4DD8988}"/>
+                <a16:creationId xmlns:a16="http://schemas.microsoft.com/office/drawing/2014/main" id="{AFE30788-1939-4911-BE09-F0BC1CBA16EC}"/>
               </a:ext>
             </a:extLst>
           </p:cNvPr>
@@ -11608,7 +11608,7 @@
     </p:spTree>
     <p:extLst>
       <p:ext uri="{BB962C8B-B14F-4D97-AF65-F5344CB8AC3E}">
-        <p14:creationId xmlns:p14="http://schemas.microsoft.com/office/powerpoint/2010/main" val="473456549"/>
+        <p14:creationId xmlns:p14="http://schemas.microsoft.com/office/powerpoint/2010/main" val="1428454290"/>
       </p:ext>
     </p:extLst>
   </p:cSld>

</xml_diff>